<commit_message>
Revise English speaker notes for classroom delivery
</commit_message>
<xml_diff>
--- a/slides/METMAP_SIGMA_BC515_Original_Workflow_Course.pptx
+++ b/slides/METMAP_SIGMA_BC515_Original_Workflow_Course.pptx
@@ -18645,7 +18645,7 @@
 </file>
 
 <file path=ppt/notesSlides/notesSlide1.xml><?xml version="1.0" encoding="utf-8"?>
-<p:notes xmlns:p="http://schemas.openxmlformats.org/presentationml/2006/main">
+<p:notes xmlns:a="http://schemas.openxmlformats.org/drawingml/2006/main" xmlns:p="http://schemas.openxmlformats.org/presentationml/2006/main">
   <p:cSld>
     <p:spTree>
       <p:nvGrpSpPr>
@@ -18654,13 +18654,13 @@
         <p:nvPr/>
       </p:nvGrpSpPr>
       <p:grpSpPr>
-        <a:xfrm xmlns:a="http://schemas.openxmlformats.org/drawingml/2006/main"/>
+        <a:xfrm/>
       </p:grpSpPr>
       <p:sp>
         <p:nvSpPr>
           <p:cNvPr id="2" name="Slide Image Placeholder 1"/>
           <p:cNvSpPr>
-            <a:spLocks xmlns:a="http://schemas.openxmlformats.org/drawingml/2006/main" noGrp="1"/>
+            <a:spLocks noGrp="1"/>
           </p:cNvSpPr>
           <p:nvPr>
             <p:ph type="sldImg" idx="0"/>
@@ -18672,7 +18672,7 @@
         <p:nvSpPr>
           <p:cNvPr id="3" name="Notes Placeholder 2"/>
           <p:cNvSpPr>
-            <a:spLocks xmlns:a="http://schemas.openxmlformats.org/drawingml/2006/main" noGrp="1"/>
+            <a:spLocks noGrp="1"/>
           </p:cNvSpPr>
           <p:nvPr>
             <p:ph type="body" idx="1"/>
@@ -18680,27 +18680,22 @@
         </p:nvSpPr>
         <p:spPr/>
         <p:txBody>
-          <a:bodyPr xmlns:a="http://schemas.openxmlformats.org/drawingml/2006/main"/>
-          <a:lstStyle xmlns:a="http://schemas.openxmlformats.org/drawingml/2006/main"/>
-          <a:p xmlns:a="http://schemas.openxmlformats.org/drawingml/2006/main">
+          <a:bodyPr/>
+          <a:lstStyle/>
+          <a:p>
             <a:r>
-              <a:t>Teaching session using four executed Jupyter notebooks. The audience should be familiar with Python arrays and basic neural-network training. All BC-515 plots and numerical summaries in this deck come from the saved runs supplied with the notebooks.</a:t>
+              <a:t>We will use one breast cancer section, BC-515, to work through MET-MAP and SIGMA. For each method, we will run the library version and then examine the same calculation written directly in a notebook. The four notebooks already contain their outputs, so we can connect each step of the code to the resulting maps and numerical summaries.</a:t>
             </a:r>
           </a:p>
-          <a:p xmlns:a="http://schemas.openxmlformats.org/drawingml/2006/main">
+          <a:p>
             <a:r>
               <a:t/>
             </a:r>
             <a:endParaRPr/>
           </a:p>
-          <a:p xmlns:a="http://schemas.openxmlformats.org/drawingml/2006/main">
+          <a:p>
             <a:r>
-              <a:t>Sources</a:t>
-            </a:r>
-          </a:p>
-          <a:p xmlns:a="http://schemas.openxmlformats.org/drawingml/2006/main">
-            <a:r>
-              <a:t>notebooks/BC515_four_implementations/index.html</a:t>
+              <a:t>Course files: README.md, 01_METMAP_library.ipynb, 02_SIGMA_library.ipynb, 03_METMAP_from_scratch.ipynb, 04_SIGMA_from_scratch.ipynb.</a:t>
             </a:r>
           </a:p>
         </p:txBody>
@@ -18709,7 +18704,7 @@
         <p:nvSpPr>
           <p:cNvPr id="4" name="Slide Number Placeholder 3"/>
           <p:cNvSpPr>
-            <a:spLocks xmlns:a="http://schemas.openxmlformats.org/drawingml/2006/main" noGrp="1"/>
+            <a:spLocks noGrp="1"/>
           </p:cNvSpPr>
           <p:nvPr>
             <p:ph type="sldNum" idx="5"/>
@@ -18717,21 +18712,21 @@
         </p:nvSpPr>
         <p:spPr/>
         <p:txBody>
-          <a:bodyPr xmlns:a="http://schemas.openxmlformats.org/drawingml/2006/main"/>
-          <a:lstStyle xmlns:a="http://schemas.openxmlformats.org/drawingml/2006/main"/>
-          <a:p xmlns:a="http://schemas.openxmlformats.org/drawingml/2006/main"/>
+          <a:bodyPr/>
+          <a:lstStyle/>
+          <a:p/>
         </p:txBody>
       </p:sp>
     </p:spTree>
   </p:cSld>
   <p:clrMapOvr>
-    <a:masterClrMapping xmlns:a="http://schemas.openxmlformats.org/drawingml/2006/main"/>
+    <a:masterClrMapping/>
   </p:clrMapOvr>
 </p:notes>
 </file>
 
 <file path=ppt/notesSlides/notesSlide10.xml><?xml version="1.0" encoding="utf-8"?>
-<p:notes xmlns:p="http://schemas.openxmlformats.org/presentationml/2006/main">
+<p:notes xmlns:a="http://schemas.openxmlformats.org/drawingml/2006/main" xmlns:p="http://schemas.openxmlformats.org/presentationml/2006/main">
   <p:cSld>
     <p:spTree>
       <p:nvGrpSpPr>
@@ -18740,13 +18735,13 @@
         <p:nvPr/>
       </p:nvGrpSpPr>
       <p:grpSpPr>
-        <a:xfrm xmlns:a="http://schemas.openxmlformats.org/drawingml/2006/main"/>
+        <a:xfrm/>
       </p:grpSpPr>
       <p:sp>
         <p:nvSpPr>
           <p:cNvPr id="2" name="Slide Image Placeholder 1"/>
           <p:cNvSpPr>
-            <a:spLocks xmlns:a="http://schemas.openxmlformats.org/drawingml/2006/main" noGrp="1"/>
+            <a:spLocks noGrp="1"/>
           </p:cNvSpPr>
           <p:nvPr>
             <p:ph type="sldImg" idx="0"/>
@@ -18758,7 +18753,7 @@
         <p:nvSpPr>
           <p:cNvPr id="3" name="Notes Placeholder 2"/>
           <p:cNvSpPr>
-            <a:spLocks xmlns:a="http://schemas.openxmlformats.org/drawingml/2006/main" noGrp="1"/>
+            <a:spLocks noGrp="1"/>
           </p:cNvSpPr>
           <p:nvPr>
             <p:ph type="body" idx="1"/>
@@ -18766,32 +18761,32 @@
         </p:nvSpPr>
         <p:spPr/>
         <p:txBody>
-          <a:bodyPr xmlns:a="http://schemas.openxmlformats.org/drawingml/2006/main"/>
-          <a:lstStyle xmlns:a="http://schemas.openxmlformats.org/drawingml/2006/main"/>
-          <a:p xmlns:a="http://schemas.openxmlformats.org/drawingml/2006/main">
+          <a:bodyPr/>
+          <a:lstStyle/>
+          <a:p>
             <a:r>
-              <a:t>Exact operations from the training loop in Notebook 03, cell 6, lines 29–38, with long statements wrapped for display. The notebook also defines the complete encoder and decoder, constructs Adam and the linear learning-rate scheduler, and exports results. expression_function[0] is the linear decoder. The numerical computation matches the library exactly.</a:t>
+              <a:t>Each iteration clears the gradients, reconstructs MSI from the spatial coordinates and adds the decoder's L1 penalty to the mean squared error. Backpropagation computes the gradients, Adam updates the parameters, and the scheduler changes the learning rate for the next step.</a:t>
             </a:r>
           </a:p>
-          <a:p xmlns:a="http://schemas.openxmlformats.org/drawingml/2006/main">
+          <a:p>
             <a:r>
               <a:t/>
             </a:r>
             <a:endParaRPr/>
           </a:p>
-          <a:p xmlns:a="http://schemas.openxmlformats.org/drawingml/2006/main">
+          <a:p>
             <a:r>
-              <a:t>Sources</a:t>
+              <a:t>Here, expression_function[0] is the linear decoder. Notebook 03 also defines the encoder, decoder and optimizer. Matching the library requires the same layer initialization and order of operations, including when losses are recorded. With those details aligned, the two saved runs give identical numerical outputs in the recorded environment.</a:t>
             </a:r>
           </a:p>
-          <a:p xmlns:a="http://schemas.openxmlformats.org/drawingml/2006/main">
+          <a:p>
             <a:r>
-              <a:t>notebooks/BC515_four_implementations/03_METMAP_from_scratch.ipynb</a:t>
+              <a:t/>
             </a:r>
           </a:p>
-          <a:p xmlns:a="http://schemas.openxmlformats.org/drawingml/2006/main">
+          <a:p>
             <a:r>
-              <a:t>external/MET-MAP/src/multi_gaston/multi_gaston.py, commit 43c9386ffe7d5b2f0f66d64d4820358c3cd8a11c</a:t>
+              <a:t>Sources: 03_METMAP_from_scratch.ipynb, vendor/MET-MAP/src/multi_gaston/multi_gaston.py, reference/implementation_parity.csv.</a:t>
             </a:r>
           </a:p>
         </p:txBody>
@@ -18800,7 +18795,7 @@
         <p:nvSpPr>
           <p:cNvPr id="4" name="Slide Number Placeholder 3"/>
           <p:cNvSpPr>
-            <a:spLocks xmlns:a="http://schemas.openxmlformats.org/drawingml/2006/main" noGrp="1"/>
+            <a:spLocks noGrp="1"/>
           </p:cNvSpPr>
           <p:nvPr>
             <p:ph type="sldNum" idx="5"/>
@@ -18808,21 +18803,21 @@
         </p:nvSpPr>
         <p:spPr/>
         <p:txBody>
-          <a:bodyPr xmlns:a="http://schemas.openxmlformats.org/drawingml/2006/main"/>
-          <a:lstStyle xmlns:a="http://schemas.openxmlformats.org/drawingml/2006/main"/>
-          <a:p xmlns:a="http://schemas.openxmlformats.org/drawingml/2006/main"/>
+          <a:bodyPr/>
+          <a:lstStyle/>
+          <a:p/>
         </p:txBody>
       </p:sp>
     </p:spTree>
   </p:cSld>
   <p:clrMapOvr>
-    <a:masterClrMapping xmlns:a="http://schemas.openxmlformats.org/drawingml/2006/main"/>
+    <a:masterClrMapping/>
   </p:clrMapOvr>
 </p:notes>
 </file>
 
 <file path=ppt/notesSlides/notesSlide11.xml><?xml version="1.0" encoding="utf-8"?>
-<p:notes xmlns:p="http://schemas.openxmlformats.org/presentationml/2006/main">
+<p:notes xmlns:a="http://schemas.openxmlformats.org/drawingml/2006/main" xmlns:p="http://schemas.openxmlformats.org/presentationml/2006/main">
   <p:cSld>
     <p:spTree>
       <p:nvGrpSpPr>
@@ -18831,13 +18826,13 @@
         <p:nvPr/>
       </p:nvGrpSpPr>
       <p:grpSpPr>
-        <a:xfrm xmlns:a="http://schemas.openxmlformats.org/drawingml/2006/main"/>
+        <a:xfrm/>
       </p:grpSpPr>
       <p:sp>
         <p:nvSpPr>
           <p:cNvPr id="2" name="Slide Image Placeholder 1"/>
           <p:cNvSpPr>
-            <a:spLocks xmlns:a="http://schemas.openxmlformats.org/drawingml/2006/main" noGrp="1"/>
+            <a:spLocks noGrp="1"/>
           </p:cNvSpPr>
           <p:nvPr>
             <p:ph type="sldImg" idx="0"/>
@@ -18849,7 +18844,7 @@
         <p:nvSpPr>
           <p:cNvPr id="3" name="Notes Placeholder 2"/>
           <p:cNvSpPr>
-            <a:spLocks xmlns:a="http://schemas.openxmlformats.org/drawingml/2006/main" noGrp="1"/>
+            <a:spLocks noGrp="1"/>
           </p:cNvSpPr>
           <p:nvPr>
             <p:ph type="body" idx="1"/>
@@ -18857,32 +18852,32 @@
         </p:nvSpPr>
         <p:spPr/>
         <p:txBody>
-          <a:bodyPr xmlns:a="http://schemas.openxmlformats.org/drawingml/2006/main"/>
-          <a:lstStyle xmlns:a="http://schemas.openxmlformats.org/drawingml/2006/main"/>
-          <a:p xmlns:a="http://schemas.openxmlformats.org/drawingml/2006/main">
+          <a:bodyPr/>
+          <a:lstStyle/>
+          <a:p>
             <a:r>
-              <a:t>The chart includes all 3,000 logged steps from training_loss.csv. Chart values are rounded to eight decimal places for the editable workbook. The original CSV retains full stored precision. The last logged total loss and post-update reconstruction MSE refer to different quantities and different points in the optimization step. The training trace assesses convergence only. It provides no held-out performance estimate.</a:t>
+              <a:t>The total training loss falls from 1.294701 to 0.804907 over 3,000 steps. The final reconstruction MSE is 0.796654. The total loss includes the L1 penalty and records the value before the parameter update. The final MSE measures reconstruction after the last update and excludes the penalty.</a:t>
             </a:r>
           </a:p>
-          <a:p xmlns:a="http://schemas.openxmlformats.org/drawingml/2006/main">
+          <a:p>
             <a:r>
               <a:t/>
             </a:r>
             <a:endParaRPr/>
           </a:p>
-          <a:p xmlns:a="http://schemas.openxmlformats.org/drawingml/2006/main">
+          <a:p>
             <a:r>
-              <a:t>Sources</a:t>
+              <a:t>The trace shows how optimization progressed on the training section. It does not tell us how well the model would reconstruct an independent section, because this run has no held-out evaluation.</a:t>
             </a:r>
           </a:p>
-          <a:p xmlns:a="http://schemas.openxmlformats.org/drawingml/2006/main">
+          <a:p>
             <a:r>
-              <a:t>notebooks/BC515_four_implementations/results/metmap_library/training_loss.csv</a:t>
+              <a:t/>
             </a:r>
           </a:p>
-          <a:p xmlns:a="http://schemas.openxmlformats.org/drawingml/2006/main">
+          <a:p>
             <a:r>
-              <a:t>notebooks/BC515_four_implementations/results/metmap_library/provenance.json</a:t>
+              <a:t>Source: 01_METMAP_library.ipynb, saved training and reconstruction outputs.</a:t>
             </a:r>
           </a:p>
         </p:txBody>
@@ -18891,7 +18886,7 @@
         <p:nvSpPr>
           <p:cNvPr id="4" name="Slide Number Placeholder 3"/>
           <p:cNvSpPr>
-            <a:spLocks xmlns:a="http://schemas.openxmlformats.org/drawingml/2006/main" noGrp="1"/>
+            <a:spLocks noGrp="1"/>
           </p:cNvSpPr>
           <p:nvPr>
             <p:ph type="sldNum" idx="5"/>
@@ -18899,21 +18894,21 @@
         </p:nvSpPr>
         <p:spPr/>
         <p:txBody>
-          <a:bodyPr xmlns:a="http://schemas.openxmlformats.org/drawingml/2006/main"/>
-          <a:lstStyle xmlns:a="http://schemas.openxmlformats.org/drawingml/2006/main"/>
-          <a:p xmlns:a="http://schemas.openxmlformats.org/drawingml/2006/main"/>
+          <a:bodyPr/>
+          <a:lstStyle/>
+          <a:p/>
         </p:txBody>
       </p:sp>
     </p:spTree>
   </p:cSld>
   <p:clrMapOvr>
-    <a:masterClrMapping xmlns:a="http://schemas.openxmlformats.org/drawingml/2006/main"/>
+    <a:masterClrMapping/>
   </p:clrMapOvr>
 </p:notes>
 </file>
 
 <file path=ppt/notesSlides/notesSlide12.xml><?xml version="1.0" encoding="utf-8"?>
-<p:notes xmlns:p="http://schemas.openxmlformats.org/presentationml/2006/main">
+<p:notes xmlns:a="http://schemas.openxmlformats.org/drawingml/2006/main" xmlns:p="http://schemas.openxmlformats.org/presentationml/2006/main">
   <p:cSld>
     <p:spTree>
       <p:nvGrpSpPr>
@@ -18922,13 +18917,13 @@
         <p:nvPr/>
       </p:nvGrpSpPr>
       <p:grpSpPr>
-        <a:xfrm xmlns:a="http://schemas.openxmlformats.org/drawingml/2006/main"/>
+        <a:xfrm/>
       </p:grpSpPr>
       <p:sp>
         <p:nvSpPr>
           <p:cNvPr id="2" name="Slide Image Placeholder 1"/>
           <p:cNvSpPr>
-            <a:spLocks xmlns:a="http://schemas.openxmlformats.org/drawingml/2006/main" noGrp="1"/>
+            <a:spLocks noGrp="1"/>
           </p:cNvSpPr>
           <p:nvPr>
             <p:ph type="sldImg" idx="0"/>
@@ -18940,7 +18935,7 @@
         <p:nvSpPr>
           <p:cNvPr id="3" name="Notes Placeholder 2"/>
           <p:cNvSpPr>
-            <a:spLocks xmlns:a="http://schemas.openxmlformats.org/drawingml/2006/main" noGrp="1"/>
+            <a:spLocks noGrp="1"/>
           </p:cNvSpPr>
           <p:nvPr>
             <p:ph type="body" idx="1"/>
@@ -18948,32 +18943,32 @@
         </p:nvSpPr>
         <p:spPr/>
         <p:txBody>
-          <a:bodyPr xmlns:a="http://schemas.openxmlformats.org/drawingml/2006/main"/>
-          <a:lstStyle xmlns:a="http://schemas.openxmlformats.org/drawingml/2006/main"/>
-          <a:p xmlns:a="http://schemas.openxmlformats.org/drawingml/2006/main">
+          <a:bodyPr/>
+          <a:lstStyle/>
+          <a:p>
             <a:r>
-              <a:t>These are the three isodepth maps from the library run. The scratch run has identical saved coordinates and isodepth arrays. The same orientation appears throughout the notebook figures: the spatial y-axis increases downward. Gradient order, sign and scale are not biologically identifiable, and an isodepth value does not measure distance from the tumor boundary.</a:t>
+              <a:t>Each map shows one of the three learned isodepths across all 3,508 spots. The colors are scaled from 0 to 1 separately for display, and the spatial y-axis increases downward, as it does in the notebook figures. The library and scratch runs produce identical saved isodepth arrays.</a:t>
             </a:r>
           </a:p>
-          <a:p xmlns:a="http://schemas.openxmlformats.org/drawingml/2006/main">
+          <a:p>
             <a:r>
               <a:t/>
             </a:r>
             <a:endParaRPr/>
           </a:p>
-          <a:p xmlns:a="http://schemas.openxmlformats.org/drawingml/2006/main">
+          <a:p>
             <a:r>
-              <a:t>Sources</a:t>
+              <a:t>An isodepth locates a spot in the learned representation of MSI variation. We can compare its spatial pattern with tissue annotations. The sign, order and scale of the axes remain arbitrary, and interpreting an axis as distance from the tumor boundary would require a separate calculation.</a:t>
             </a:r>
           </a:p>
-          <a:p xmlns:a="http://schemas.openxmlformats.org/drawingml/2006/main">
+          <a:p>
             <a:r>
-              <a:t>notebooks/BC515_four_implementations/results/metmap_library/spatial_gradients.png</a:t>
+              <a:t/>
             </a:r>
           </a:p>
-          <a:p xmlns:a="http://schemas.openxmlformats.org/drawingml/2006/main">
+          <a:p>
             <a:r>
-              <a:t>notebooks/BC515_four_implementations/implementation_parity.csv</a:t>
+              <a:t>Sources: 01_METMAP_library.ipynb, reference/implementation_parity.csv.</a:t>
             </a:r>
           </a:p>
         </p:txBody>
@@ -18982,7 +18977,7 @@
         <p:nvSpPr>
           <p:cNvPr id="4" name="Slide Number Placeholder 3"/>
           <p:cNvSpPr>
-            <a:spLocks xmlns:a="http://schemas.openxmlformats.org/drawingml/2006/main" noGrp="1"/>
+            <a:spLocks noGrp="1"/>
           </p:cNvSpPr>
           <p:nvPr>
             <p:ph type="sldNum" idx="5"/>
@@ -18990,21 +18985,21 @@
         </p:nvSpPr>
         <p:spPr/>
         <p:txBody>
-          <a:bodyPr xmlns:a="http://schemas.openxmlformats.org/drawingml/2006/main"/>
-          <a:lstStyle xmlns:a="http://schemas.openxmlformats.org/drawingml/2006/main"/>
-          <a:p xmlns:a="http://schemas.openxmlformats.org/drawingml/2006/main"/>
+          <a:bodyPr/>
+          <a:lstStyle/>
+          <a:p/>
         </p:txBody>
       </p:sp>
     </p:spTree>
   </p:cSld>
   <p:clrMapOvr>
-    <a:masterClrMapping xmlns:a="http://schemas.openxmlformats.org/drawingml/2006/main"/>
+    <a:masterClrMapping/>
   </p:clrMapOvr>
 </p:notes>
 </file>
 
 <file path=ppt/notesSlides/notesSlide13.xml><?xml version="1.0" encoding="utf-8"?>
-<p:notes xmlns:p="http://schemas.openxmlformats.org/presentationml/2006/main">
+<p:notes xmlns:a="http://schemas.openxmlformats.org/drawingml/2006/main" xmlns:p="http://schemas.openxmlformats.org/presentationml/2006/main">
   <p:cSld>
     <p:spTree>
       <p:nvGrpSpPr>
@@ -19013,13 +19008,13 @@
         <p:nvPr/>
       </p:nvGrpSpPr>
       <p:grpSpPr>
-        <a:xfrm xmlns:a="http://schemas.openxmlformats.org/drawingml/2006/main"/>
+        <a:xfrm/>
       </p:grpSpPr>
       <p:sp>
         <p:nvSpPr>
           <p:cNvPr id="2" name="Slide Image Placeholder 1"/>
           <p:cNvSpPr>
-            <a:spLocks xmlns:a="http://schemas.openxmlformats.org/drawingml/2006/main" noGrp="1"/>
+            <a:spLocks noGrp="1"/>
           </p:cNvSpPr>
           <p:nvPr>
             <p:ph type="sldImg" idx="0"/>
@@ -19031,7 +19026,7 @@
         <p:nvSpPr>
           <p:cNvPr id="3" name="Notes Placeholder 2"/>
           <p:cNvSpPr>
-            <a:spLocks xmlns:a="http://schemas.openxmlformats.org/drawingml/2006/main" noGrp="1"/>
+            <a:spLocks noGrp="1"/>
           </p:cNvSpPr>
           <p:nvPr>
             <p:ph type="body" idx="1"/>
@@ -19039,32 +19034,32 @@
         </p:nvSpPr>
         <p:spPr/>
         <p:txBody>
-          <a:bodyPr xmlns:a="http://schemas.openxmlformats.org/drawingml/2006/main"/>
-          <a:lstStyle xmlns:a="http://schemas.openxmlformats.org/drawingml/2006/main"/>
-          <a:p xmlns:a="http://schemas.openxmlformats.org/drawingml/2006/main">
+          <a:bodyPr/>
+          <a:lstStyle/>
+          <a:p>
             <a:r>
-              <a:t>The displayed features rank highly by reconstruction R² in the training data. R² retains negative values for poorly reconstructed features. A high value indicates that a feature follows the learned spatial representation in this section. It does not identify the compound or prove biological relevance. The ranking also reports abs(decoder weight) multiplied by the standard deviation of each raw isodepth.</a:t>
+              <a:t>These features have high reconstruction R² within the training section. For m/z 293.0480, R² is 0.887339, meaning that its spatial variation is well represented by the fitted model. The ranking retains negative R² values for features that are poorly reconstructed.</a:t>
             </a:r>
           </a:p>
-          <a:p xmlns:a="http://schemas.openxmlformats.org/drawingml/2006/main">
+          <a:p>
             <a:r>
               <a:t/>
             </a:r>
             <a:endParaRPr/>
           </a:p>
-          <a:p xmlns:a="http://schemas.openxmlformats.org/drawingml/2006/main">
+          <a:p>
             <a:r>
-              <a:t>Sources</a:t>
+              <a:t>The ranking also includes each absolute decoder weight multiplied by the standard deviation of its isodepth. This accounts for the scale of the learned axis when describing its contribution to a feature. Chemical identification and biological interpretation require evidence beyond the reconstruction fit.</a:t>
             </a:r>
           </a:p>
-          <a:p xmlns:a="http://schemas.openxmlformats.org/drawingml/2006/main">
+          <a:p>
             <a:r>
-              <a:t>notebooks/BC515_four_implementations/results/metmap_library/metabolite_ranking.csv</a:t>
+              <a:t/>
             </a:r>
           </a:p>
-          <a:p xmlns:a="http://schemas.openxmlformats.org/drawingml/2006/main">
+          <a:p>
             <a:r>
-              <a:t>notebooks/BC515_four_implementations/results/metmap_library/representative_metabolites.png</a:t>
+              <a:t>Source: 01_METMAP_library.ipynb, saved feature ranking and reconstructed metabolite maps.</a:t>
             </a:r>
           </a:p>
         </p:txBody>
@@ -19073,7 +19068,7 @@
         <p:nvSpPr>
           <p:cNvPr id="4" name="Slide Number Placeholder 3"/>
           <p:cNvSpPr>
-            <a:spLocks xmlns:a="http://schemas.openxmlformats.org/drawingml/2006/main" noGrp="1"/>
+            <a:spLocks noGrp="1"/>
           </p:cNvSpPr>
           <p:nvPr>
             <p:ph type="sldNum" idx="5"/>
@@ -19081,21 +19076,21 @@
         </p:nvSpPr>
         <p:spPr/>
         <p:txBody>
-          <a:bodyPr xmlns:a="http://schemas.openxmlformats.org/drawingml/2006/main"/>
-          <a:lstStyle xmlns:a="http://schemas.openxmlformats.org/drawingml/2006/main"/>
-          <a:p xmlns:a="http://schemas.openxmlformats.org/drawingml/2006/main"/>
+          <a:bodyPr/>
+          <a:lstStyle/>
+          <a:p/>
         </p:txBody>
       </p:sp>
     </p:spTree>
   </p:cSld>
   <p:clrMapOvr>
-    <a:masterClrMapping xmlns:a="http://schemas.openxmlformats.org/drawingml/2006/main"/>
+    <a:masterClrMapping/>
   </p:clrMapOvr>
 </p:notes>
 </file>
 
 <file path=ppt/notesSlides/notesSlide14.xml><?xml version="1.0" encoding="utf-8"?>
-<p:notes xmlns:p="http://schemas.openxmlformats.org/presentationml/2006/main">
+<p:notes xmlns:a="http://schemas.openxmlformats.org/drawingml/2006/main" xmlns:p="http://schemas.openxmlformats.org/presentationml/2006/main">
   <p:cSld>
     <p:spTree>
       <p:nvGrpSpPr>
@@ -19104,13 +19099,13 @@
         <p:nvPr/>
       </p:nvGrpSpPr>
       <p:grpSpPr>
-        <a:xfrm xmlns:a="http://schemas.openxmlformats.org/drawingml/2006/main"/>
+        <a:xfrm/>
       </p:grpSpPr>
       <p:sp>
         <p:nvSpPr>
           <p:cNvPr id="2" name="Slide Image Placeholder 1"/>
           <p:cNvSpPr>
-            <a:spLocks xmlns:a="http://schemas.openxmlformats.org/drawingml/2006/main" noGrp="1"/>
+            <a:spLocks noGrp="1"/>
           </p:cNvSpPr>
           <p:nvPr>
             <p:ph type="sldImg" idx="0"/>
@@ -19122,7 +19117,7 @@
         <p:nvSpPr>
           <p:cNvPr id="3" name="Notes Placeholder 2"/>
           <p:cNvSpPr>
-            <a:spLocks xmlns:a="http://schemas.openxmlformats.org/drawingml/2006/main" noGrp="1"/>
+            <a:spLocks noGrp="1"/>
           </p:cNvSpPr>
           <p:nvPr>
             <p:ph type="body" idx="1"/>
@@ -19130,32 +19125,32 @@
         </p:nvSpPr>
         <p:spPr/>
         <p:txBody>
-          <a:bodyPr xmlns:a="http://schemas.openxmlformats.org/drawingml/2006/main"/>
-          <a:lstStyle xmlns:a="http://schemas.openxmlformats.org/drawingml/2006/main"/>
-          <a:p xmlns:a="http://schemas.openxmlformats.org/drawingml/2006/main">
+          <a:bodyPr/>
+          <a:lstStyle/>
+          <a:p>
             <a:r>
-              <a:t>Use the uns MSI matrix explicitly. The spatial graph contains 15 outgoing edges per spot before adding network self-loops. The Gaussian kernel bandwidth is the median positive neighbor distance. RNA integration upstream of X_harmony is outside this lesson. The positive BCE weight is 2707/724.</a:t>
+              <a:t>SIGMA reads the MSI intensities from adata.uns['msi']. After log1p and robust scaling, it reduces the 2,086 features to 64 SVD components and standardizes them. The spatial graph connects each spot to its 15 nearest neighbors. The median positive neighbor distance sets the Gaussian bandwidth.</a:t>
             </a:r>
           </a:p>
-          <a:p xmlns:a="http://schemas.openxmlformats.org/drawingml/2006/main">
+          <a:p>
             <a:r>
               <a:t/>
             </a:r>
             <a:endParaRPr/>
           </a:p>
-          <a:p xmlns:a="http://schemas.openxmlformats.org/drawingml/2006/main">
+          <a:p>
             <a:r>
-              <a:t>Sources</a:t>
+              <a:t>The RNA target uses the first 32 Harmony dimensions already stored in the data file. Tumor and Stroma labels provide 3,431 supervised anchors, with a positive-class weight of 2707/724. The 77 unlabelled spots still contribute to graph calculations and reconstruction. The notebooks start from the supplied Harmony representation.</a:t>
             </a:r>
           </a:p>
-          <a:p xmlns:a="http://schemas.openxmlformats.org/drawingml/2006/main">
+          <a:p>
             <a:r>
-              <a:t>sigma_spatial_pypi_starter/src/sigma_spatial</a:t>
+              <a:t/>
             </a:r>
           </a:p>
-          <a:p xmlns:a="http://schemas.openxmlformats.org/drawingml/2006/main">
+          <a:p>
             <a:r>
-              <a:t>notebooks/BC515_four_implementations/02_SIGMA_library.ipynb</a:t>
+              <a:t>Sources: 02_SIGMA_library.ipynb, vendor/SIGMA/src/sigma_spatial/.</a:t>
             </a:r>
           </a:p>
         </p:txBody>
@@ -19164,7 +19159,7 @@
         <p:nvSpPr>
           <p:cNvPr id="4" name="Slide Number Placeholder 3"/>
           <p:cNvSpPr>
-            <a:spLocks xmlns:a="http://schemas.openxmlformats.org/drawingml/2006/main" noGrp="1"/>
+            <a:spLocks noGrp="1"/>
           </p:cNvSpPr>
           <p:nvPr>
             <p:ph type="sldNum" idx="5"/>
@@ -19172,21 +19167,21 @@
         </p:nvSpPr>
         <p:spPr/>
         <p:txBody>
-          <a:bodyPr xmlns:a="http://schemas.openxmlformats.org/drawingml/2006/main"/>
-          <a:lstStyle xmlns:a="http://schemas.openxmlformats.org/drawingml/2006/main"/>
-          <a:p xmlns:a="http://schemas.openxmlformats.org/drawingml/2006/main"/>
+          <a:bodyPr/>
+          <a:lstStyle/>
+          <a:p/>
         </p:txBody>
       </p:sp>
     </p:spTree>
   </p:cSld>
   <p:clrMapOvr>
-    <a:masterClrMapping xmlns:a="http://schemas.openxmlformats.org/drawingml/2006/main"/>
+    <a:masterClrMapping/>
   </p:clrMapOvr>
 </p:notes>
 </file>
 
 <file path=ppt/notesSlides/notesSlide15.xml><?xml version="1.0" encoding="utf-8"?>
-<p:notes xmlns:p="http://schemas.openxmlformats.org/presentationml/2006/main">
+<p:notes xmlns:a="http://schemas.openxmlformats.org/drawingml/2006/main" xmlns:p="http://schemas.openxmlformats.org/presentationml/2006/main">
   <p:cSld>
     <p:spTree>
       <p:nvGrpSpPr>
@@ -19195,13 +19190,13 @@
         <p:nvPr/>
       </p:nvGrpSpPr>
       <p:grpSpPr>
-        <a:xfrm xmlns:a="http://schemas.openxmlformats.org/drawingml/2006/main"/>
+        <a:xfrm/>
       </p:grpSpPr>
       <p:sp>
         <p:nvSpPr>
           <p:cNvPr id="2" name="Slide Image Placeholder 1"/>
           <p:cNvSpPr>
-            <a:spLocks xmlns:a="http://schemas.openxmlformats.org/drawingml/2006/main" noGrp="1"/>
+            <a:spLocks noGrp="1"/>
           </p:cNvSpPr>
           <p:nvPr>
             <p:ph type="sldImg" idx="0"/>
@@ -19213,7 +19208,7 @@
         <p:nvSpPr>
           <p:cNvPr id="3" name="Notes Placeholder 2"/>
           <p:cNvSpPr>
-            <a:spLocks xmlns:a="http://schemas.openxmlformats.org/drawingml/2006/main" noGrp="1"/>
+            <a:spLocks noGrp="1"/>
           </p:cNvSpPr>
           <p:nvPr>
             <p:ph type="body" idx="1"/>
@@ -19221,37 +19216,32 @@
         </p:nvSpPr>
         <p:spPr/>
         <p:txBody>
-          <a:bodyPr xmlns:a="http://schemas.openxmlformats.org/drawingml/2006/main"/>
-          <a:lstStyle xmlns:a="http://schemas.openxmlformats.org/drawingml/2006/main"/>
-          <a:p xmlns:a="http://schemas.openxmlformats.org/drawingml/2006/main">
+          <a:bodyPr/>
+          <a:lstStyle/>
+          <a:p>
             <a:r>
-              <a:t>Preprocessing diffusion averages over outgoing neighbors and divides by weighted outgoing degree. This operation differs from the GraphLowPass layer inside the network. A separate 50-step clamped Gaussian field propagates label anchors for reference and export. That anchor field is not an input to the classification head. Anchor labels affect the model through the supervised BCE term.</a:t>
+              <a:t>At each diffusion step, a spot takes 90% of its weighted neighbor average and 10% of its original MSI embedding. After ten steps, G contains the smoothed representation. Subtracting G from E gives the residual R that the network will predict.</a:t>
             </a:r>
           </a:p>
-          <a:p xmlns:a="http://schemas.openxmlformats.org/drawingml/2006/main">
+          <a:p>
             <a:r>
               <a:t/>
             </a:r>
             <a:endParaRPr/>
           </a:p>
-          <a:p xmlns:a="http://schemas.openxmlformats.org/drawingml/2006/main">
+          <a:p>
             <a:r>
-              <a:t>Sources</a:t>
+              <a:t>This averaging step divides by the sum of outgoing edge weights. The network uses a different normalization, which we will examine next. The code also propagates the label anchors through a separate clamped field for 50 steps. It exports that field as a reference. The classification head receives supervision through the anchor loss.</a:t>
             </a:r>
           </a:p>
-          <a:p xmlns:a="http://schemas.openxmlformats.org/drawingml/2006/main">
+          <a:p>
             <a:r>
-              <a:t>sigma_spatial_pypi_starter/src/sigma_spatial/graph.py</a:t>
+              <a:t/>
             </a:r>
           </a:p>
-          <a:p xmlns:a="http://schemas.openxmlformats.org/drawingml/2006/main">
+          <a:p>
             <a:r>
-              <a:t>sigma_spatial_pypi_starter/src/sigma_spatial/pipeline.py</a:t>
-            </a:r>
-          </a:p>
-          <a:p xmlns:a="http://schemas.openxmlformats.org/drawingml/2006/main">
-            <a:r>
-              <a:t>notebooks/BC515_four_implementations/04_SIGMA_from_scratch.ipynb</a:t>
+              <a:t>Sources: 04_SIGMA_from_scratch.ipynb, vendor/SIGMA/src/sigma_spatial/graph.py, vendor/SIGMA/src/sigma_spatial/pipeline.py.</a:t>
             </a:r>
           </a:p>
         </p:txBody>
@@ -19260,7 +19250,7 @@
         <p:nvSpPr>
           <p:cNvPr id="4" name="Slide Number Placeholder 3"/>
           <p:cNvSpPr>
-            <a:spLocks xmlns:a="http://schemas.openxmlformats.org/drawingml/2006/main" noGrp="1"/>
+            <a:spLocks noGrp="1"/>
           </p:cNvSpPr>
           <p:nvPr>
             <p:ph type="sldNum" idx="5"/>
@@ -19268,21 +19258,21 @@
         </p:nvSpPr>
         <p:spPr/>
         <p:txBody>
-          <a:bodyPr xmlns:a="http://schemas.openxmlformats.org/drawingml/2006/main"/>
-          <a:lstStyle xmlns:a="http://schemas.openxmlformats.org/drawingml/2006/main"/>
-          <a:p xmlns:a="http://schemas.openxmlformats.org/drawingml/2006/main"/>
+          <a:bodyPr/>
+          <a:lstStyle/>
+          <a:p/>
         </p:txBody>
       </p:sp>
     </p:spTree>
   </p:cSld>
   <p:clrMapOvr>
-    <a:masterClrMapping xmlns:a="http://schemas.openxmlformats.org/drawingml/2006/main"/>
+    <a:masterClrMapping/>
   </p:clrMapOvr>
 </p:notes>
 </file>
 
 <file path=ppt/notesSlides/notesSlide16.xml><?xml version="1.0" encoding="utf-8"?>
-<p:notes xmlns:p="http://schemas.openxmlformats.org/presentationml/2006/main">
+<p:notes xmlns:a="http://schemas.openxmlformats.org/drawingml/2006/main" xmlns:p="http://schemas.openxmlformats.org/presentationml/2006/main">
   <p:cSld>
     <p:spTree>
       <p:nvGrpSpPr>
@@ -19291,13 +19281,13 @@
         <p:nvPr/>
       </p:nvGrpSpPr>
       <p:grpSpPr>
-        <a:xfrm xmlns:a="http://schemas.openxmlformats.org/drawingml/2006/main"/>
+        <a:xfrm/>
       </p:grpSpPr>
       <p:sp>
         <p:nvSpPr>
           <p:cNvPr id="2" name="Slide Image Placeholder 1"/>
           <p:cNvSpPr>
-            <a:spLocks xmlns:a="http://schemas.openxmlformats.org/drawingml/2006/main" noGrp="1"/>
+            <a:spLocks noGrp="1"/>
           </p:cNvSpPr>
           <p:nvPr>
             <p:ph type="sldImg" idx="0"/>
@@ -19309,7 +19299,7 @@
         <p:nvSpPr>
           <p:cNvPr id="3" name="Notes Placeholder 2"/>
           <p:cNvSpPr>
-            <a:spLocks xmlns:a="http://schemas.openxmlformats.org/drawingml/2006/main" noGrp="1"/>
+            <a:spLocks noGrp="1"/>
           </p:cNvSpPr>
           <p:nvPr>
             <p:ph type="body" idx="1"/>
@@ -19317,37 +19307,42 @@
         </p:nvSpPr>
         <p:spPr/>
         <p:txBody>
-          <a:bodyPr xmlns:a="http://schemas.openxmlformats.org/drawingml/2006/main"/>
-          <a:lstStyle xmlns:a="http://schemas.openxmlformats.org/drawingml/2006/main"/>
-          <a:p xmlns:a="http://schemas.openxmlformats.org/drawingml/2006/main">
+          <a:bodyPr/>
+          <a:lstStyle/>
+          <a:p>
             <a:r>
-              <a:t>The model input is G. Two high-pass blocks produce the hidden representation used by all three heads. The implementation uses PyTorch Geometric source-to-target propagation. GraphLowPass adds weight-1 self-loops and normalizes using incoming edge counts, not the sum of incoming edge weights. Preserve this detail when reproducing the source. It is not a conventional undirected weighted normalized Laplacian.</a:t>
+              <a:t>The network takes G as input. Each block subtracts a low-pass graph output before applying the linear layer, LayerNorm, ReLU and dropout. The shared representation feeds heads for the MSI residual, RNA target and region logit.</a:t>
             </a:r>
           </a:p>
-          <a:p xmlns:a="http://schemas.openxmlformats.org/drawingml/2006/main">
+          <a:p>
             <a:r>
               <a:t/>
             </a:r>
             <a:endParaRPr/>
           </a:p>
-          <a:p xmlns:a="http://schemas.openxmlformats.org/drawingml/2006/main">
+          <a:p>
             <a:r>
-              <a:t>Sources</a:t>
+              <a:t>The loss combines residual SmoothL1 with weighted binary cross-entropy on the labelled spots and RNA mean squared error. The last two terms each have weight 0.05. Training uses Adam for 1,000 epochs.</a:t>
             </a:r>
           </a:p>
-          <a:p xmlns:a="http://schemas.openxmlformats.org/drawingml/2006/main">
+          <a:p>
             <a:r>
-              <a:t>sigma_spatial_pypi_starter/src/sigma_spatial/model.py</a:t>
+              <a:t/>
             </a:r>
           </a:p>
-          <a:p xmlns:a="http://schemas.openxmlformats.org/drawingml/2006/main">
+          <a:p>
             <a:r>
-              <a:t>sigma_spatial_pypi_starter/src/sigma_spatial/graph.py</a:t>
+              <a:t>GraphLowPass uses PyTorch Geometric source-to-target propagation. It adds self-loops with weight 1 and uses incoming edge counts in its normalization. Substituting a weighted-degree normalization would change the model's calculations.</a:t>
             </a:r>
           </a:p>
-          <a:p xmlns:a="http://schemas.openxmlformats.org/drawingml/2006/main">
+          <a:p>
             <a:r>
-              <a:t>notebooks/BC515_four_implementations/04_SIGMA_from_scratch.ipynb</a:t>
+              <a:t/>
+            </a:r>
+          </a:p>
+          <a:p>
+            <a:r>
+              <a:t>Sources: 04_SIGMA_from_scratch.ipynb, vendor/SIGMA/src/sigma_spatial/model.py, vendor/SIGMA/src/sigma_spatial/graph.py.</a:t>
             </a:r>
           </a:p>
         </p:txBody>
@@ -19356,7 +19351,7 @@
         <p:nvSpPr>
           <p:cNvPr id="4" name="Slide Number Placeholder 3"/>
           <p:cNvSpPr>
-            <a:spLocks xmlns:a="http://schemas.openxmlformats.org/drawingml/2006/main" noGrp="1"/>
+            <a:spLocks noGrp="1"/>
           </p:cNvSpPr>
           <p:nvPr>
             <p:ph type="sldNum" idx="5"/>
@@ -19364,21 +19359,21 @@
         </p:nvSpPr>
         <p:spPr/>
         <p:txBody>
-          <a:bodyPr xmlns:a="http://schemas.openxmlformats.org/drawingml/2006/main"/>
-          <a:lstStyle xmlns:a="http://schemas.openxmlformats.org/drawingml/2006/main"/>
-          <a:p xmlns:a="http://schemas.openxmlformats.org/drawingml/2006/main"/>
+          <a:bodyPr/>
+          <a:lstStyle/>
+          <a:p/>
         </p:txBody>
       </p:sp>
     </p:spTree>
   </p:cSld>
   <p:clrMapOvr>
-    <a:masterClrMapping xmlns:a="http://schemas.openxmlformats.org/drawingml/2006/main"/>
+    <a:masterClrMapping/>
   </p:clrMapOvr>
 </p:notes>
 </file>
 
 <file path=ppt/notesSlides/notesSlide17.xml><?xml version="1.0" encoding="utf-8"?>
-<p:notes xmlns:p="http://schemas.openxmlformats.org/presentationml/2006/main">
+<p:notes xmlns:a="http://schemas.openxmlformats.org/drawingml/2006/main" xmlns:p="http://schemas.openxmlformats.org/presentationml/2006/main">
   <p:cSld>
     <p:spTree>
       <p:nvGrpSpPr>
@@ -19387,13 +19382,13 @@
         <p:nvPr/>
       </p:nvGrpSpPr>
       <p:grpSpPr>
-        <a:xfrm xmlns:a="http://schemas.openxmlformats.org/drawingml/2006/main"/>
+        <a:xfrm/>
       </p:grpSpPr>
       <p:sp>
         <p:nvSpPr>
           <p:cNvPr id="2" name="Slide Image Placeholder 1"/>
           <p:cNvSpPr>
-            <a:spLocks xmlns:a="http://schemas.openxmlformats.org/drawingml/2006/main" noGrp="1"/>
+            <a:spLocks noGrp="1"/>
           </p:cNvSpPr>
           <p:nvPr>
             <p:ph type="sldImg" idx="0"/>
@@ -19405,7 +19400,7 @@
         <p:nvSpPr>
           <p:cNvPr id="3" name="Notes Placeholder 2"/>
           <p:cNvSpPr>
-            <a:spLocks xmlns:a="http://schemas.openxmlformats.org/drawingml/2006/main" noGrp="1"/>
+            <a:spLocks noGrp="1"/>
           </p:cNvSpPr>
           <p:nvPr>
             <p:ph type="body" idx="1"/>
@@ -19413,11 +19408,31 @@
         </p:nvSpPr>
         <p:spPr/>
         <p:txBody>
-          <a:bodyPr xmlns:a="http://schemas.openxmlformats.org/drawingml/2006/main"/>
-          <a:lstStyle xmlns:a="http://schemas.openxmlformats.org/drawingml/2006/main"/>
-          <a:p xmlns:a="http://schemas.openxmlformats.org/drawingml/2006/main">
+          <a:bodyPr/>
+          <a:lstStyle/>
+          <a:p>
             <a:r>
-              <a:t>Notebook 02 imports SIGMA 0.3.1+bc515.original from vendor/SIGMA/src. This compatibility snapshot restores the original RNA-first output initialization, division-before-multiplication diffusion, original class-weight dtype, NumPy sigmoid and downstream raw-intensity profile operations. The separate scratch notebook defines these operations directly. Source: vendor/SIGMA/ORIGINAL_COMPATIBILITY.md and ORIGINAL_PROTOCOL.md.</a:t>
+              <a:t>The source-path cell loads SIGMA from vendor/SIGMA/src. The version check should return 0.3.1+bc515.original. The fit call then specifies the annotation labels, RNA target and training settings used for BC-515.</a:t>
+            </a:r>
+          </a:p>
+          <a:p>
+            <a:r>
+              <a:t/>
+            </a:r>
+          </a:p>
+          <a:p>
+            <a:r>
+              <a:t>Several small implementation choices matter for reproducing this run. The RNA output head initializes first. Diffusion divides before multiplying, the class weight keeps its original dtype, and the output score uses NumPy's sigmoid calculation. The downstream analysis works from raw MSI intensities. Notebook 04 writes these same operations directly in its cells.</a:t>
+            </a:r>
+          </a:p>
+          <a:p>
+            <a:r>
+              <a:t/>
+            </a:r>
+          </a:p>
+          <a:p>
+            <a:r>
+              <a:t>Sources: 02_SIGMA_library.ipynb, vendor/SIGMA/ORIGINAL_COMPATIBILITY.md, ORIGINAL_PROTOCOL.md.</a:t>
             </a:r>
           </a:p>
         </p:txBody>
@@ -19426,7 +19441,7 @@
         <p:nvSpPr>
           <p:cNvPr id="4" name="Slide Number Placeholder 3"/>
           <p:cNvSpPr>
-            <a:spLocks xmlns:a="http://schemas.openxmlformats.org/drawingml/2006/main" noGrp="1"/>
+            <a:spLocks noGrp="1"/>
           </p:cNvSpPr>
           <p:nvPr>
             <p:ph type="sldNum" idx="5"/>
@@ -19434,21 +19449,21 @@
         </p:nvSpPr>
         <p:spPr/>
         <p:txBody>
-          <a:bodyPr xmlns:a="http://schemas.openxmlformats.org/drawingml/2006/main"/>
-          <a:lstStyle xmlns:a="http://schemas.openxmlformats.org/drawingml/2006/main"/>
-          <a:p xmlns:a="http://schemas.openxmlformats.org/drawingml/2006/main"/>
+          <a:bodyPr/>
+          <a:lstStyle/>
+          <a:p/>
         </p:txBody>
       </p:sp>
     </p:spTree>
   </p:cSld>
   <p:clrMapOvr>
-    <a:masterClrMapping xmlns:a="http://schemas.openxmlformats.org/drawingml/2006/main"/>
+    <a:masterClrMapping/>
   </p:clrMapOvr>
 </p:notes>
 </file>
 
 <file path=ppt/notesSlides/notesSlide18.xml><?xml version="1.0" encoding="utf-8"?>
-<p:notes xmlns:p="http://schemas.openxmlformats.org/presentationml/2006/main">
+<p:notes xmlns:a="http://schemas.openxmlformats.org/drawingml/2006/main" xmlns:p="http://schemas.openxmlformats.org/presentationml/2006/main">
   <p:cSld>
     <p:spTree>
       <p:nvGrpSpPr>
@@ -19457,13 +19472,13 @@
         <p:nvPr/>
       </p:nvGrpSpPr>
       <p:grpSpPr>
-        <a:xfrm xmlns:a="http://schemas.openxmlformats.org/drawingml/2006/main"/>
+        <a:xfrm/>
       </p:grpSpPr>
       <p:sp>
         <p:nvSpPr>
           <p:cNvPr id="2" name="Slide Image Placeholder 1"/>
           <p:cNvSpPr>
-            <a:spLocks xmlns:a="http://schemas.openxmlformats.org/drawingml/2006/main" noGrp="1"/>
+            <a:spLocks noGrp="1"/>
           </p:cNvSpPr>
           <p:nvPr>
             <p:ph type="sldImg" idx="0"/>
@@ -19475,7 +19490,7 @@
         <p:nvSpPr>
           <p:cNvPr id="3" name="Notes Placeholder 2"/>
           <p:cNvSpPr>
-            <a:spLocks xmlns:a="http://schemas.openxmlformats.org/drawingml/2006/main" noGrp="1"/>
+            <a:spLocks noGrp="1"/>
           </p:cNvSpPr>
           <p:nvPr>
             <p:ph type="body" idx="1"/>
@@ -19483,37 +19498,32 @@
         </p:nvSpPr>
         <p:spPr/>
         <p:txBody>
-          <a:bodyPr xmlns:a="http://schemas.openxmlformats.org/drawingml/2006/main"/>
-          <a:lstStyle xmlns:a="http://schemas.openxmlformats.org/drawingml/2006/main"/>
-          <a:p xmlns:a="http://schemas.openxmlformats.org/drawingml/2006/main">
+          <a:bodyPr/>
+          <a:lstStyle/>
+          <a:p>
             <a:r>
-              <a:t>The min–max normalized sigmoid score is section-specific and should not be read as a calibrated probability. The legacy boundary rule requires both same-side and opposite-side neighbors. Distance is Euclidean to the nearest boundary spot, not a continuous contour. No conversion to micrometres has been verified. A valid boundary is required to define the distance output.</a:t>
+              <a:t>The sigmoid output is rescaled from 0 to 1 within this section. A score of at least 0.5 assigns a spot to the inside. These scores depend on the section and have no probability calibration.</a:t>
             </a:r>
           </a:p>
-          <a:p xmlns:a="http://schemas.openxmlformats.org/drawingml/2006/main">
+          <a:p>
             <a:r>
               <a:t/>
             </a:r>
             <a:endParaRPr/>
           </a:p>
-          <a:p xmlns:a="http://schemas.openxmlformats.org/drawingml/2006/main">
+          <a:p>
             <a:r>
-              <a:t>Sources</a:t>
+              <a:t>For the legacy boundary rule, a spot needs both same-side and opposite-side spots among its ten neighbors. We then measure Euclidean distance to the nearest boundary spot, assign a negative sign inside and a positive sign outside, and set boundary spots to zero. The distance uses the input coordinate units. A physical interpretation in micrometres would require a verified coordinate conversion.</a:t>
             </a:r>
           </a:p>
-          <a:p xmlns:a="http://schemas.openxmlformats.org/drawingml/2006/main">
+          <a:p>
             <a:r>
-              <a:t>sigma_spatial_pypi_starter/src/sigma_spatial</a:t>
+              <a:t/>
             </a:r>
           </a:p>
-          <a:p xmlns:a="http://schemas.openxmlformats.org/drawingml/2006/main">
+          <a:p>
             <a:r>
-              <a:t>notebooks/BC515_four_implementations/02_SIGMA_library.ipynb</a:t>
-            </a:r>
-          </a:p>
-          <a:p xmlns:a="http://schemas.openxmlformats.org/drawingml/2006/main">
-            <a:r>
-              <a:t>notebooks/BC515_four_implementations/04_SIGMA_from_scratch.ipynb</a:t>
+              <a:t>Sources: 02_SIGMA_library.ipynb, 04_SIGMA_from_scratch.ipynb.</a:t>
             </a:r>
           </a:p>
         </p:txBody>
@@ -19522,7 +19532,7 @@
         <p:nvSpPr>
           <p:cNvPr id="4" name="Slide Number Placeholder 3"/>
           <p:cNvSpPr>
-            <a:spLocks xmlns:a="http://schemas.openxmlformats.org/drawingml/2006/main" noGrp="1"/>
+            <a:spLocks noGrp="1"/>
           </p:cNvSpPr>
           <p:nvPr>
             <p:ph type="sldNum" idx="5"/>
@@ -19530,21 +19540,21 @@
         </p:nvSpPr>
         <p:spPr/>
         <p:txBody>
-          <a:bodyPr xmlns:a="http://schemas.openxmlformats.org/drawingml/2006/main"/>
-          <a:lstStyle xmlns:a="http://schemas.openxmlformats.org/drawingml/2006/main"/>
-          <a:p xmlns:a="http://schemas.openxmlformats.org/drawingml/2006/main"/>
+          <a:bodyPr/>
+          <a:lstStyle/>
+          <a:p/>
         </p:txBody>
       </p:sp>
     </p:spTree>
   </p:cSld>
   <p:clrMapOvr>
-    <a:masterClrMapping xmlns:a="http://schemas.openxmlformats.org/drawingml/2006/main"/>
+    <a:masterClrMapping/>
   </p:clrMapOvr>
 </p:notes>
 </file>
 
 <file path=ppt/notesSlides/notesSlide19.xml><?xml version="1.0" encoding="utf-8"?>
-<p:notes xmlns:p="http://schemas.openxmlformats.org/presentationml/2006/main">
+<p:notes xmlns:a="http://schemas.openxmlformats.org/drawingml/2006/main" xmlns:p="http://schemas.openxmlformats.org/presentationml/2006/main">
   <p:cSld>
     <p:spTree>
       <p:nvGrpSpPr>
@@ -19553,13 +19563,13 @@
         <p:nvPr/>
       </p:nvGrpSpPr>
       <p:grpSpPr>
-        <a:xfrm xmlns:a="http://schemas.openxmlformats.org/drawingml/2006/main"/>
+        <a:xfrm/>
       </p:grpSpPr>
       <p:sp>
         <p:nvSpPr>
           <p:cNvPr id="2" name="Slide Image Placeholder 1"/>
           <p:cNvSpPr>
-            <a:spLocks xmlns:a="http://schemas.openxmlformats.org/drawingml/2006/main" noGrp="1"/>
+            <a:spLocks noGrp="1"/>
           </p:cNvSpPr>
           <p:nvPr>
             <p:ph type="sldImg" idx="0"/>
@@ -19571,7 +19581,7 @@
         <p:nvSpPr>
           <p:cNvPr id="3" name="Notes Placeholder 2"/>
           <p:cNvSpPr>
-            <a:spLocks xmlns:a="http://schemas.openxmlformats.org/drawingml/2006/main" noGrp="1"/>
+            <a:spLocks noGrp="1"/>
           </p:cNvSpPr>
           <p:nvPr>
             <p:ph type="body" idx="1"/>
@@ -19579,16 +19589,34 @@
         </p:nvSpPr>
         <p:spPr/>
         <p:txBody>
-          <a:bodyPr xmlns:a="http://schemas.openxmlformats.org/drawingml/2006/main"/>
-          <a:lstStyle xmlns:a="http://schemas.openxmlformats.org/drawingml/2006/main"/>
-          <a:p xmlns:a="http://schemas.openxmlformats.org/drawingml/2006/main">
+          <a:bodyPr/>
+          <a:lstStyle/>
+          <a:p>
             <a:r>
-              <a:t>These figures come from the newly executed original-protocol library notebook. Inside spots: 751; boundary spots: 838. Seed 0, CPU, 1,000 epochs. Training loss: 0.42529410123825073 to 0.155556321144104. Historical original-notebook counts are 752 and 834. The historical notebook did not record a complete runtime specification. Compare the newly executed original code and restored implementation in the same environment; do not assume exact agreement with every historical saved value.</a:t>
+              <a:t>With seed 0 and 1,000 epochs on CPU, this run gives 751 inside spots and 838 boundary spots. The training loss falls from 0.425294 to 0.155556. The maps show where the resulting region split places the interface.</a:t>
             </a:r>
           </a:p>
-          <a:p xmlns:a="http://schemas.openxmlformats.org/drawingml/2006/main">
+          <a:p>
             <a:r>
-              <a:t>Source: 02_SIGMA_library.ipynb and its saved outputs.</a:t>
+              <a:t/>
+            </a:r>
+            <a:endParaRPr/>
+          </a:p>
+          <a:p>
+            <a:r>
+              <a:t>An earlier saved original notebook contains 752 inside spots and 834 boundary spots, without a complete runtime record. For the comparison in this course, both SIGMA implementations agree with the original code when all three run in the same environment.</a:t>
+            </a:r>
+            <a:endParaRPr/>
+          </a:p>
+          <a:p>
+            <a:r>
+              <a:t/>
+            </a:r>
+            <a:endParaRPr/>
+          </a:p>
+          <a:p>
+            <a:r>
+              <a:t>Sources: 02_SIGMA_library.ipynb, reference/sigma_library_summary.json, reference/original_protocol_comparison.csv.</a:t>
             </a:r>
             <a:endParaRPr/>
           </a:p>
@@ -19598,7 +19626,7 @@
         <p:nvSpPr>
           <p:cNvPr id="4" name="Slide Number Placeholder 3"/>
           <p:cNvSpPr>
-            <a:spLocks xmlns:a="http://schemas.openxmlformats.org/drawingml/2006/main" noGrp="1"/>
+            <a:spLocks noGrp="1"/>
           </p:cNvSpPr>
           <p:nvPr>
             <p:ph type="sldNum" idx="5"/>
@@ -19606,21 +19634,21 @@
         </p:nvSpPr>
         <p:spPr/>
         <p:txBody>
-          <a:bodyPr xmlns:a="http://schemas.openxmlformats.org/drawingml/2006/main"/>
-          <a:lstStyle xmlns:a="http://schemas.openxmlformats.org/drawingml/2006/main"/>
-          <a:p xmlns:a="http://schemas.openxmlformats.org/drawingml/2006/main"/>
+          <a:bodyPr/>
+          <a:lstStyle/>
+          <a:p/>
         </p:txBody>
       </p:sp>
     </p:spTree>
   </p:cSld>
   <p:clrMapOvr>
-    <a:masterClrMapping xmlns:a="http://schemas.openxmlformats.org/drawingml/2006/main"/>
+    <a:masterClrMapping/>
   </p:clrMapOvr>
 </p:notes>
 </file>
 
 <file path=ppt/notesSlides/notesSlide2.xml><?xml version="1.0" encoding="utf-8"?>
-<p:notes xmlns:p="http://schemas.openxmlformats.org/presentationml/2006/main">
+<p:notes xmlns:a="http://schemas.openxmlformats.org/drawingml/2006/main" xmlns:p="http://schemas.openxmlformats.org/presentationml/2006/main">
   <p:cSld>
     <p:spTree>
       <p:nvGrpSpPr>
@@ -19629,13 +19657,13 @@
         <p:nvPr/>
       </p:nvGrpSpPr>
       <p:grpSpPr>
-        <a:xfrm xmlns:a="http://schemas.openxmlformats.org/drawingml/2006/main"/>
+        <a:xfrm/>
       </p:grpSpPr>
       <p:sp>
         <p:nvSpPr>
           <p:cNvPr id="2" name="Slide Image Placeholder 1"/>
           <p:cNvSpPr>
-            <a:spLocks xmlns:a="http://schemas.openxmlformats.org/drawingml/2006/main" noGrp="1"/>
+            <a:spLocks noGrp="1"/>
           </p:cNvSpPr>
           <p:nvPr>
             <p:ph type="sldImg" idx="0"/>
@@ -19647,7 +19675,7 @@
         <p:nvSpPr>
           <p:cNvPr id="3" name="Notes Placeholder 2"/>
           <p:cNvSpPr>
-            <a:spLocks xmlns:a="http://schemas.openxmlformats.org/drawingml/2006/main" noGrp="1"/>
+            <a:spLocks noGrp="1"/>
           </p:cNvSpPr>
           <p:nvPr>
             <p:ph type="body" idx="1"/>
@@ -19655,32 +19683,32 @@
         </p:nvSpPr>
         <p:spPr/>
         <p:txBody>
-          <a:bodyPr xmlns:a="http://schemas.openxmlformats.org/drawingml/2006/main"/>
-          <a:lstStyle xmlns:a="http://schemas.openxmlformats.org/drawingml/2006/main"/>
-          <a:p xmlns:a="http://schemas.openxmlformats.org/drawingml/2006/main">
+          <a:bodyPr/>
+          <a:lstStyle/>
+          <a:p>
             <a:r>
-              <a:t>Both approaches summarize spatial metabolic variation, but their objectives and outputs differ. The raw training losses therefore cannot compare method quality. MET-MAP receives no pathological labels in this run. SIGMA uses the available Tumor and Stroma labels as training anchors and the first 32 Harmony dimensions as an auxiliary target.</a:t>
+              <a:t>MET-MAP asks which continuous spatial gradients explain the measured metabolic variation. It learns from MSI intensities and spatial coordinates. SIGMA uses a different reference: a pathological interface learned with Tumor and Stroma labels. In this BC-515 run, it also uses the first 32 Harmony dimensions as an RNA target.</a:t>
             </a:r>
           </a:p>
-          <a:p xmlns:a="http://schemas.openxmlformats.org/drawingml/2006/main">
+          <a:p>
             <a:r>
               <a:t/>
             </a:r>
             <a:endParaRPr/>
           </a:p>
-          <a:p xmlns:a="http://schemas.openxmlformats.org/drawingml/2006/main">
+          <a:p>
             <a:r>
-              <a:t>Sources</a:t>
+              <a:t>MET-MAP produces learned spatial coordinates. SIGMA produces a region score and distance from its estimated boundary. Each loss measures a different objective, so comparing the two loss values would not tell us which method performs better.</a:t>
             </a:r>
           </a:p>
-          <a:p xmlns:a="http://schemas.openxmlformats.org/drawingml/2006/main">
+          <a:p>
             <a:r>
-              <a:t>external/MET-MAP/src/multi_gaston/multi_gaston.py, commit 43c9386ffe7d5b2f0f66d64d4820358c3cd8a11c</a:t>
+              <a:t/>
             </a:r>
           </a:p>
-          <a:p xmlns:a="http://schemas.openxmlformats.org/drawingml/2006/main">
+          <a:p>
             <a:r>
-              <a:t>sigma_spatial_pypi_starter/src/sigma_spatial</a:t>
+              <a:t>Sources: vendor/MET-MAP/src/multi_gaston/multi_gaston.py, upstream commit 43c9386ffe7d5b2f0f66d64d4820358c3cd8a11c, vendor/SIGMA/src/sigma_spatial/.</a:t>
             </a:r>
             <a:endParaRPr/>
           </a:p>
@@ -19690,7 +19718,7 @@
         <p:nvSpPr>
           <p:cNvPr id="4" name="Slide Number Placeholder 3"/>
           <p:cNvSpPr>
-            <a:spLocks xmlns:a="http://schemas.openxmlformats.org/drawingml/2006/main" noGrp="1"/>
+            <a:spLocks noGrp="1"/>
           </p:cNvSpPr>
           <p:nvPr>
             <p:ph type="sldNum" idx="5"/>
@@ -19698,21 +19726,21 @@
         </p:nvSpPr>
         <p:spPr/>
         <p:txBody>
-          <a:bodyPr xmlns:a="http://schemas.openxmlformats.org/drawingml/2006/main"/>
-          <a:lstStyle xmlns:a="http://schemas.openxmlformats.org/drawingml/2006/main"/>
-          <a:p xmlns:a="http://schemas.openxmlformats.org/drawingml/2006/main"/>
+          <a:bodyPr/>
+          <a:lstStyle/>
+          <a:p/>
         </p:txBody>
       </p:sp>
     </p:spTree>
   </p:cSld>
   <p:clrMapOvr>
-    <a:masterClrMapping xmlns:a="http://schemas.openxmlformats.org/drawingml/2006/main"/>
+    <a:masterClrMapping/>
   </p:clrMapOvr>
 </p:notes>
 </file>
 
 <file path=ppt/notesSlides/notesSlide20.xml><?xml version="1.0" encoding="utf-8"?>
-<p:notes xmlns:p="http://schemas.openxmlformats.org/presentationml/2006/main">
+<p:notes xmlns:a="http://schemas.openxmlformats.org/drawingml/2006/main" xmlns:p="http://schemas.openxmlformats.org/presentationml/2006/main">
   <p:cSld>
     <p:spTree>
       <p:nvGrpSpPr>
@@ -19721,13 +19749,13 @@
         <p:nvPr/>
       </p:nvGrpSpPr>
       <p:grpSpPr>
-        <a:xfrm xmlns:a="http://schemas.openxmlformats.org/drawingml/2006/main"/>
+        <a:xfrm/>
       </p:grpSpPr>
       <p:sp>
         <p:nvSpPr>
           <p:cNvPr id="2" name="Slide Image Placeholder 1"/>
           <p:cNvSpPr>
-            <a:spLocks xmlns:a="http://schemas.openxmlformats.org/drawingml/2006/main" noGrp="1"/>
+            <a:spLocks noGrp="1"/>
           </p:cNvSpPr>
           <p:nvPr>
             <p:ph type="sldImg" idx="0"/>
@@ -19739,7 +19767,7 @@
         <p:nvSpPr>
           <p:cNvPr id="3" name="Notes Placeholder 2"/>
           <p:cNvSpPr>
-            <a:spLocks xmlns:a="http://schemas.openxmlformats.org/drawingml/2006/main" noGrp="1"/>
+            <a:spLocks noGrp="1"/>
           </p:cNvSpPr>
           <p:nvPr>
             <p:ph type="body" idx="1"/>
@@ -19747,11 +19775,41 @@
         </p:nvSpPr>
         <p:spPr/>
         <p:txBody>
-          <a:bodyPr xmlns:a="http://schemas.openxmlformats.org/drawingml/2006/main"/>
-          <a:lstStyle xmlns:a="http://schemas.openxmlformats.org/drawingml/2006/main"/>
-          <a:p xmlns:a="http://schemas.openxmlformats.org/drawingml/2006/main">
+          <a:bodyPr/>
+          <a:lstStyle/>
+          <a:p>
             <a:r>
-              <a:t>Original BC-515 workflow: rank the top 2,000 variance-selected MSI features with Huber regression on log1p(intensity minus its minimum) versus absolute distance. Require at least 300 observations, a negative slope, R² at least 0.05 and near/far enrichment at least 1.05; trim lambda above the 99th percentile. Near and far thresholds are the 20th and 80th distance percentiles. Take the first 300 features and calculate eight-sector anisotropy. Build raw-intensity signed-distance profiles between the 2nd and 98th percentiles with 40 bins; require at least five spots per bin and 80% defined bins. Interpolate missing bins, normalize each profile, and use Ward clustering with four groups. Select a representative within each group after its 90th-percentile lambda trim, then rank by R² and enrichment. Source: original HBC_515_SIGMA.ipynb cells 21, 26, 32, 34–36 and 110; revised notebooks.</a:t>
+              <a:t>For each of the 2,000 most variable MSI features, fit log1p(I minus its minimum) against absolute distance using Huber regression. A negative slope gives the decay length, lambda = -1/slope. Keep fits with at least 300 observations, R² of at least 0.05 and near-to-far enrichment of at least 1.05. The near and far cutoffs use the 20th and 80th distance percentiles. Remove lambda values above the 99th percentile, then rank by R² and enrichment.</a:t>
+            </a:r>
+          </a:p>
+          <a:p>
+            <a:r>
+              <a:t/>
+            </a:r>
+          </a:p>
+          <a:p>
+            <a:r>
+              <a:t>For the leading 300 features, calculate anisotropy across eight sectors and build profiles in 40 signed-distance bins between the 2nd and 98th percentiles. A bin needs five spots, and a profile needs 80% of its bins defined. Interpolate missing bins, z-score each profile and apply Ward clustering with four groups.</a:t>
+            </a:r>
+          </a:p>
+          <a:p>
+            <a:r>
+              <a:t/>
+            </a:r>
+          </a:p>
+          <a:p>
+            <a:r>
+              <a:t>Within each group, trim lambda above its 90th percentile when candidates remain, then choose the representative by R² and enrichment.</a:t>
+            </a:r>
+          </a:p>
+          <a:p>
+            <a:r>
+              <a:t/>
+            </a:r>
+          </a:p>
+          <a:p>
+            <a:r>
+              <a:t>Sources: 02_SIGMA_library.ipynb, 04_SIGMA_from_scratch.ipynb, ORIGINAL_PROTOCOL.md.</a:t>
             </a:r>
           </a:p>
         </p:txBody>
@@ -19760,7 +19818,7 @@
         <p:nvSpPr>
           <p:cNvPr id="4" name="Slide Number Placeholder 3"/>
           <p:cNvSpPr>
-            <a:spLocks xmlns:a="http://schemas.openxmlformats.org/drawingml/2006/main" noGrp="1"/>
+            <a:spLocks noGrp="1"/>
           </p:cNvSpPr>
           <p:nvPr>
             <p:ph type="sldNum" idx="5"/>
@@ -19768,21 +19826,21 @@
         </p:nvSpPr>
         <p:spPr/>
         <p:txBody>
-          <a:bodyPr xmlns:a="http://schemas.openxmlformats.org/drawingml/2006/main"/>
-          <a:lstStyle xmlns:a="http://schemas.openxmlformats.org/drawingml/2006/main"/>
-          <a:p xmlns:a="http://schemas.openxmlformats.org/drawingml/2006/main"/>
+          <a:bodyPr/>
+          <a:lstStyle/>
+          <a:p/>
         </p:txBody>
       </p:sp>
     </p:spTree>
   </p:cSld>
   <p:clrMapOvr>
-    <a:masterClrMapping xmlns:a="http://schemas.openxmlformats.org/drawingml/2006/main"/>
+    <a:masterClrMapping/>
   </p:clrMapOvr>
 </p:notes>
 </file>
 
 <file path=ppt/notesSlides/notesSlide21.xml><?xml version="1.0" encoding="utf-8"?>
-<p:notes xmlns:p="http://schemas.openxmlformats.org/presentationml/2006/main">
+<p:notes xmlns:a="http://schemas.openxmlformats.org/drawingml/2006/main" xmlns:p="http://schemas.openxmlformats.org/presentationml/2006/main">
   <p:cSld>
     <p:spTree>
       <p:nvGrpSpPr>
@@ -19791,13 +19849,13 @@
         <p:nvPr/>
       </p:nvGrpSpPr>
       <p:grpSpPr>
-        <a:xfrm xmlns:a="http://schemas.openxmlformats.org/drawingml/2006/main"/>
+        <a:xfrm/>
       </p:grpSpPr>
       <p:sp>
         <p:nvSpPr>
           <p:cNvPr id="2" name="Slide Image Placeholder 1"/>
           <p:cNvSpPr>
-            <a:spLocks xmlns:a="http://schemas.openxmlformats.org/drawingml/2006/main" noGrp="1"/>
+            <a:spLocks noGrp="1"/>
           </p:cNvSpPr>
           <p:nvPr>
             <p:ph type="sldImg" idx="0"/>
@@ -19809,7 +19867,7 @@
         <p:nvSpPr>
           <p:cNvPr id="3" name="Notes Placeholder 2"/>
           <p:cNvSpPr>
-            <a:spLocks xmlns:a="http://schemas.openxmlformats.org/drawingml/2006/main" noGrp="1"/>
+            <a:spLocks noGrp="1"/>
           </p:cNvSpPr>
           <p:nvPr>
             <p:ph type="body" idx="1"/>
@@ -19817,11 +19875,41 @@
         </p:nvSpPr>
         <p:spPr/>
         <p:txBody>
-          <a:bodyPr xmlns:a="http://schemas.openxmlformats.org/drawingml/2006/main"/>
-          <a:lstStyle xmlns:a="http://schemas.openxmlformats.org/drawingml/2006/main"/>
-          <a:p xmlns:a="http://schemas.openxmlformats.org/drawingml/2006/main">
+          <a:bodyPr/>
+          <a:lstStyle/>
+          <a:p>
             <a:r>
-              <a:t>Each column represents one of the four Ward clusters. Within each cluster, exclude lambda above its 90th percentile when candidates remain, then rank by fit R² and boundary enrichment. Representatives are m/z 817.534520, 818.540767, 887.561462 and 328.057840. Maps show normalized raw intensity. Curves use absolute distance in input coordinate units and 30 quantile bins. Lambda and R² describe the raw-intensity log1p decay fit. The original display convention retains that fit slope and recomputes an intercept on normalized intensity; the dashed display trend is not a separately estimated normalized-intensity decay length. Program clustering instead uses 40 signed-distance bins. Source: revised 02_SIGMA_library.ipynb, program_representatives.csv and representative_distance_profiles.csv.</a:t>
+              <a:t>The four columns show one representative from each metabolic program: m/z 817.534520, 818.540767, 887.561462 and 328.057840. The maps show normalized raw intensity. The profiles below use absolute distance in the input coordinate units, grouped into 30 quantile bins.</a:t>
+            </a:r>
+          </a:p>
+          <a:p>
+            <a:r>
+              <a:t/>
+            </a:r>
+          </a:p>
+          <a:p>
+            <a:r>
+              <a:t>Lambda and R² come from the log1p decay fit on raw intensity. To draw the dashed trend, the original plotting code keeps that fitted slope and recalculates the intercept using normalized intensity. This display adjustment leaves the reported decay length unchanged.</a:t>
+            </a:r>
+          </a:p>
+          <a:p>
+            <a:r>
+              <a:t/>
+            </a:r>
+          </a:p>
+          <a:p>
+            <a:r>
+              <a:t>The clustering step uses a separate set of 40 signed-distance bins, which preserves the distinction between the two sides of the interface. The absolute-distance plots here summarize how intensity changes with distance from the interface.</a:t>
+            </a:r>
+          </a:p>
+          <a:p>
+            <a:r>
+              <a:t/>
+            </a:r>
+          </a:p>
+          <a:p>
+            <a:r>
+              <a:t>Sources: 02_SIGMA_library.ipynb, ORIGINAL_PROTOCOL.md, SLIDE_NOTES.md.</a:t>
             </a:r>
           </a:p>
         </p:txBody>
@@ -19830,7 +19918,7 @@
         <p:nvSpPr>
           <p:cNvPr id="4" name="Slide Number Placeholder 3"/>
           <p:cNvSpPr>
-            <a:spLocks xmlns:a="http://schemas.openxmlformats.org/drawingml/2006/main" noGrp="1"/>
+            <a:spLocks noGrp="1"/>
           </p:cNvSpPr>
           <p:nvPr>
             <p:ph type="sldNum" idx="5"/>
@@ -19838,21 +19926,21 @@
         </p:nvSpPr>
         <p:spPr/>
         <p:txBody>
-          <a:bodyPr xmlns:a="http://schemas.openxmlformats.org/drawingml/2006/main"/>
-          <a:lstStyle xmlns:a="http://schemas.openxmlformats.org/drawingml/2006/main"/>
-          <a:p xmlns:a="http://schemas.openxmlformats.org/drawingml/2006/main"/>
+          <a:bodyPr/>
+          <a:lstStyle/>
+          <a:p/>
         </p:txBody>
       </p:sp>
     </p:spTree>
   </p:cSld>
   <p:clrMapOvr>
-    <a:masterClrMapping xmlns:a="http://schemas.openxmlformats.org/drawingml/2006/main"/>
+    <a:masterClrMapping/>
   </p:clrMapOvr>
 </p:notes>
 </file>
 
 <file path=ppt/notesSlides/notesSlide22.xml><?xml version="1.0" encoding="utf-8"?>
-<p:notes xmlns:p="http://schemas.openxmlformats.org/presentationml/2006/main">
+<p:notes xmlns:a="http://schemas.openxmlformats.org/drawingml/2006/main" xmlns:p="http://schemas.openxmlformats.org/presentationml/2006/main">
   <p:cSld>
     <p:spTree>
       <p:nvGrpSpPr>
@@ -19861,13 +19949,13 @@
         <p:nvPr/>
       </p:nvGrpSpPr>
       <p:grpSpPr>
-        <a:xfrm xmlns:a="http://schemas.openxmlformats.org/drawingml/2006/main"/>
+        <a:xfrm/>
       </p:grpSpPr>
       <p:sp>
         <p:nvSpPr>
           <p:cNvPr id="2" name="Slide Image Placeholder 1"/>
           <p:cNvSpPr>
-            <a:spLocks xmlns:a="http://schemas.openxmlformats.org/drawingml/2006/main" noGrp="1"/>
+            <a:spLocks noGrp="1"/>
           </p:cNvSpPr>
           <p:nvPr>
             <p:ph type="sldImg" idx="0"/>
@@ -19879,7 +19967,7 @@
         <p:nvSpPr>
           <p:cNvPr id="3" name="Notes Placeholder 2"/>
           <p:cNvSpPr>
-            <a:spLocks xmlns:a="http://schemas.openxmlformats.org/drawingml/2006/main" noGrp="1"/>
+            <a:spLocks noGrp="1"/>
           </p:cNvSpPr>
           <p:nvPr>
             <p:ph type="body" idx="1"/>
@@ -19887,37 +19975,32 @@
         </p:nvSpPr>
         <p:spPr/>
         <p:txBody>
-          <a:bodyPr xmlns:a="http://schemas.openxmlformats.org/drawingml/2006/main"/>
-          <a:lstStyle xmlns:a="http://schemas.openxmlformats.org/drawingml/2006/main"/>
-          <a:p xmlns:a="http://schemas.openxmlformats.org/drawingml/2006/main">
+          <a:bodyPr/>
+          <a:lstStyle/>
+          <a:p>
             <a:r>
-              <a:t>Exact SpectralHighPassBlock definition from Notebook 04, cell 10, lines 21–31. GraphLowPass is defined earlier in the same cell using PyTorch Geometric MessagePassing. The key implementation distinction is that preprocessing diffusion divides by weighted outgoing degree, whereas the PyG network layer normalizes with incoming edge counts. Replacing either operation with a familiar but different graph normalization would break parity.</a:t>
+              <a:t>The subtraction x - self.lowpass(x, edge_index, edge_weight) is the high-pass calculation. The block then applies a linear layer, LayerNorm, ReLU and dropout. Notebook 04 defines GraphLowPass immediately before this class, so the full graph operation is available to inspect.</a:t>
             </a:r>
           </a:p>
-          <a:p xmlns:a="http://schemas.openxmlformats.org/drawingml/2006/main">
+          <a:p>
             <a:r>
               <a:t/>
             </a:r>
             <a:endParaRPr/>
           </a:p>
-          <a:p xmlns:a="http://schemas.openxmlformats.org/drawingml/2006/main">
+          <a:p>
             <a:r>
-              <a:t>Sources</a:t>
+              <a:t>When implementing it, keep the two normalizations separate. Preprocessing diffusion divides by weighted outgoing degree. The network layer uses incoming edge counts and adds self-loops with weight 1. Matching these operations is necessary to reproduce the library output.</a:t>
             </a:r>
           </a:p>
-          <a:p xmlns:a="http://schemas.openxmlformats.org/drawingml/2006/main">
+          <a:p>
             <a:r>
-              <a:t>notebooks/BC515_four_implementations/04_SIGMA_from_scratch.ipynb</a:t>
+              <a:t/>
             </a:r>
           </a:p>
-          <a:p xmlns:a="http://schemas.openxmlformats.org/drawingml/2006/main">
+          <a:p>
             <a:r>
-              <a:t>sigma_spatial_pypi_starter/src/sigma_spatial/model.py</a:t>
-            </a:r>
-          </a:p>
-          <a:p xmlns:a="http://schemas.openxmlformats.org/drawingml/2006/main">
-            <a:r>
-              <a:t>sigma_spatial_pypi_starter/src/sigma_spatial/graph.py</a:t>
+              <a:t>Sources: 04_SIGMA_from_scratch.ipynb, vendor/SIGMA/src/sigma_spatial/model.py, vendor/SIGMA/src/sigma_spatial/graph.py.</a:t>
             </a:r>
           </a:p>
         </p:txBody>
@@ -19926,7 +20009,7 @@
         <p:nvSpPr>
           <p:cNvPr id="4" name="Slide Number Placeholder 3"/>
           <p:cNvSpPr>
-            <a:spLocks xmlns:a="http://schemas.openxmlformats.org/drawingml/2006/main" noGrp="1"/>
+            <a:spLocks noGrp="1"/>
           </p:cNvSpPr>
           <p:nvPr>
             <p:ph type="sldNum" idx="5"/>
@@ -19934,21 +20017,21 @@
         </p:nvSpPr>
         <p:spPr/>
         <p:txBody>
-          <a:bodyPr xmlns:a="http://schemas.openxmlformats.org/drawingml/2006/main"/>
-          <a:lstStyle xmlns:a="http://schemas.openxmlformats.org/drawingml/2006/main"/>
-          <a:p xmlns:a="http://schemas.openxmlformats.org/drawingml/2006/main"/>
+          <a:bodyPr/>
+          <a:lstStyle/>
+          <a:p/>
         </p:txBody>
       </p:sp>
     </p:spTree>
   </p:cSld>
   <p:clrMapOvr>
-    <a:masterClrMapping xmlns:a="http://schemas.openxmlformats.org/drawingml/2006/main"/>
+    <a:masterClrMapping/>
   </p:clrMapOvr>
 </p:notes>
 </file>
 
 <file path=ppt/notesSlides/notesSlide23.xml><?xml version="1.0" encoding="utf-8"?>
-<p:notes xmlns:p="http://schemas.openxmlformats.org/presentationml/2006/main">
+<p:notes xmlns:a="http://schemas.openxmlformats.org/drawingml/2006/main" xmlns:p="http://schemas.openxmlformats.org/presentationml/2006/main">
   <p:cSld>
     <p:spTree>
       <p:nvGrpSpPr>
@@ -19957,13 +20040,13 @@
         <p:nvPr/>
       </p:nvGrpSpPr>
       <p:grpSpPr>
-        <a:xfrm xmlns:a="http://schemas.openxmlformats.org/drawingml/2006/main"/>
+        <a:xfrm/>
       </p:grpSpPr>
       <p:sp>
         <p:nvSpPr>
           <p:cNvPr id="2" name="Slide Image Placeholder 1"/>
           <p:cNvSpPr>
-            <a:spLocks xmlns:a="http://schemas.openxmlformats.org/drawingml/2006/main" noGrp="1"/>
+            <a:spLocks noGrp="1"/>
           </p:cNvSpPr>
           <p:nvPr>
             <p:ph type="sldImg" idx="0"/>
@@ -19975,7 +20058,7 @@
         <p:nvSpPr>
           <p:cNvPr id="3" name="Notes Placeholder 2"/>
           <p:cNvSpPr>
-            <a:spLocks xmlns:a="http://schemas.openxmlformats.org/drawingml/2006/main" noGrp="1"/>
+            <a:spLocks noGrp="1"/>
           </p:cNvSpPr>
           <p:nvPr>
             <p:ph type="body" idx="1"/>
@@ -19983,11 +20066,31 @@
         </p:nvSpPr>
         <p:spPr/>
         <p:txBody>
-          <a:bodyPr xmlns:a="http://schemas.openxmlformats.org/drawingml/2006/main"/>
-          <a:lstStyle xmlns:a="http://schemas.openxmlformats.org/drawingml/2006/main"/>
-          <a:p xmlns:a="http://schemas.openxmlformats.org/drawingml/2006/main">
+          <a:bodyPr/>
+          <a:lstStyle/>
+          <a:p>
             <a:r>
-              <a:t>15 recorded MET-MAP library/scratch comparisons are retained from the original executed teaching notebooks. The newly executed SIGMA notebooks pass 21 library/scratch comparisons. Both SIGMA implementations also match separately executed original core and downstream notebook code in 62 comparisons, all with maximum absolute difference 0. The comparison includes training losses, scores, boundary masks, signed distance, decay rankings, profile matrices, program labels, module scores and representatives. This establishes computational agreement in the recorded runtime, not independent biological validation or equality with every historical saved value. Sources: reference/verification.json, reference/implementation_parity.csv, reference/original_protocol_comparison.csv.</a:t>
+              <a:t>The two MET-MAP notebooks agree in 15 comparisons, and the two SIGMA notebooks agree in 21. Both SIGMA implementations also agree with a separate execution of the original code in 62 comparisons. Every recorded maximum absolute difference is zero.</a:t>
+            </a:r>
+          </a:p>
+          <a:p>
+            <a:r>
+              <a:t/>
+            </a:r>
+          </a:p>
+          <a:p>
+            <a:r>
+              <a:t>The checks cover training losses and model outputs, including the boundary masks and signed distances. They also compare the decay rankings, profile matrices, program assignments, module scores and representative features. The agreement applies to the recorded input and runtime. Repeating the comparison on another platform requires checking its results again.</a:t>
+            </a:r>
+          </a:p>
+          <a:p>
+            <a:r>
+              <a:t/>
+            </a:r>
+          </a:p>
+          <a:p>
+            <a:r>
+              <a:t>Sources: reference/verification.json, reference/implementation_parity.csv, reference/original_protocol_comparison.csv.</a:t>
             </a:r>
           </a:p>
         </p:txBody>
@@ -19996,7 +20099,7 @@
         <p:nvSpPr>
           <p:cNvPr id="4" name="Slide Number Placeholder 3"/>
           <p:cNvSpPr>
-            <a:spLocks xmlns:a="http://schemas.openxmlformats.org/drawingml/2006/main" noGrp="1"/>
+            <a:spLocks noGrp="1"/>
           </p:cNvSpPr>
           <p:nvPr>
             <p:ph type="sldNum" idx="5"/>
@@ -20004,21 +20107,21 @@
         </p:nvSpPr>
         <p:spPr/>
         <p:txBody>
-          <a:bodyPr xmlns:a="http://schemas.openxmlformats.org/drawingml/2006/main"/>
-          <a:lstStyle xmlns:a="http://schemas.openxmlformats.org/drawingml/2006/main"/>
-          <a:p xmlns:a="http://schemas.openxmlformats.org/drawingml/2006/main"/>
+          <a:bodyPr/>
+          <a:lstStyle/>
+          <a:p/>
         </p:txBody>
       </p:sp>
     </p:spTree>
   </p:cSld>
   <p:clrMapOvr>
-    <a:masterClrMapping xmlns:a="http://schemas.openxmlformats.org/drawingml/2006/main"/>
+    <a:masterClrMapping/>
   </p:clrMapOvr>
 </p:notes>
 </file>
 
 <file path=ppt/notesSlides/notesSlide24.xml><?xml version="1.0" encoding="utf-8"?>
-<p:notes xmlns:p="http://schemas.openxmlformats.org/presentationml/2006/main">
+<p:notes xmlns:a="http://schemas.openxmlformats.org/drawingml/2006/main" xmlns:p="http://schemas.openxmlformats.org/presentationml/2006/main">
   <p:cSld>
     <p:spTree>
       <p:nvGrpSpPr>
@@ -20027,13 +20130,13 @@
         <p:nvPr/>
       </p:nvGrpSpPr>
       <p:grpSpPr>
-        <a:xfrm xmlns:a="http://schemas.openxmlformats.org/drawingml/2006/main"/>
+        <a:xfrm/>
       </p:grpSpPr>
       <p:sp>
         <p:nvSpPr>
           <p:cNvPr id="2" name="Slide Image Placeholder 1"/>
           <p:cNvSpPr>
-            <a:spLocks xmlns:a="http://schemas.openxmlformats.org/drawingml/2006/main" noGrp="1"/>
+            <a:spLocks noGrp="1"/>
           </p:cNvSpPr>
           <p:nvPr>
             <p:ph type="sldImg" idx="0"/>
@@ -20045,7 +20148,7 @@
         <p:nvSpPr>
           <p:cNvPr id="3" name="Notes Placeholder 2"/>
           <p:cNvSpPr>
-            <a:spLocks xmlns:a="http://schemas.openxmlformats.org/drawingml/2006/main" noGrp="1"/>
+            <a:spLocks noGrp="1"/>
           </p:cNvSpPr>
           <p:nvPr>
             <p:ph type="body" idx="1"/>
@@ -20053,11 +20156,31 @@
         </p:nvSpPr>
         <p:spPr/>
         <p:txBody>
-          <a:bodyPr xmlns:a="http://schemas.openxmlformats.org/drawingml/2006/main"/>
-          <a:lstStyle xmlns:a="http://schemas.openxmlformats.org/drawingml/2006/main"/>
-          <a:p xmlns:a="http://schemas.openxmlformats.org/drawingml/2006/main">
+          <a:bodyPr/>
+          <a:lstStyle/>
+          <a:p>
             <a:r>
-              <a:t>The command executes each notebook in a fresh kernel and saves real outputs. The final cells compare paired results. Files under results/ are generated locally and excluded from the public source bundle. Source: execute_notebook.py and README.md.</a:t>
+              <a:t>Run these commands from the repository folder. The execution script starts each notebook in a fresh kernel and saves the outputs back into the notebook. It also writes results under results/.</a:t>
+            </a:r>
+          </a:p>
+          <a:p>
+            <a:r>
+              <a:t/>
+            </a:r>
+          </a:p>
+          <a:p>
+            <a:r>
+              <a:t>Run both notebooks for a method before checking their final comparison cells. Those cells load the paired outputs and report any differences. Keep a copy of the downloaded notebooks if you want to retain the supplied figures alongside your own run.</a:t>
+            </a:r>
+          </a:p>
+          <a:p>
+            <a:r>
+              <a:t/>
+            </a:r>
+          </a:p>
+          <a:p>
+            <a:r>
+              <a:t>Sources: execute_notebook.py, README.md.</a:t>
             </a:r>
           </a:p>
         </p:txBody>
@@ -20066,7 +20189,7 @@
         <p:nvSpPr>
           <p:cNvPr id="4" name="Slide Number Placeholder 3"/>
           <p:cNvSpPr>
-            <a:spLocks xmlns:a="http://schemas.openxmlformats.org/drawingml/2006/main" noGrp="1"/>
+            <a:spLocks noGrp="1"/>
           </p:cNvSpPr>
           <p:nvPr>
             <p:ph type="sldNum" idx="5"/>
@@ -20074,21 +20197,21 @@
         </p:nvSpPr>
         <p:spPr/>
         <p:txBody>
-          <a:bodyPr xmlns:a="http://schemas.openxmlformats.org/drawingml/2006/main"/>
-          <a:lstStyle xmlns:a="http://schemas.openxmlformats.org/drawingml/2006/main"/>
-          <a:p xmlns:a="http://schemas.openxmlformats.org/drawingml/2006/main"/>
+          <a:bodyPr/>
+          <a:lstStyle/>
+          <a:p/>
         </p:txBody>
       </p:sp>
     </p:spTree>
   </p:cSld>
   <p:clrMapOvr>
-    <a:masterClrMapping xmlns:a="http://schemas.openxmlformats.org/drawingml/2006/main"/>
+    <a:masterClrMapping/>
   </p:clrMapOvr>
 </p:notes>
 </file>
 
 <file path=ppt/notesSlides/notesSlide25.xml><?xml version="1.0" encoding="utf-8"?>
-<p:notes xmlns:p="http://schemas.openxmlformats.org/presentationml/2006/main">
+<p:notes xmlns:a="http://schemas.openxmlformats.org/drawingml/2006/main" xmlns:p="http://schemas.openxmlformats.org/presentationml/2006/main">
   <p:cSld>
     <p:spTree>
       <p:nvGrpSpPr>
@@ -20097,13 +20220,13 @@
         <p:nvPr/>
       </p:nvGrpSpPr>
       <p:grpSpPr>
-        <a:xfrm xmlns:a="http://schemas.openxmlformats.org/drawingml/2006/main"/>
+        <a:xfrm/>
       </p:grpSpPr>
       <p:sp>
         <p:nvSpPr>
           <p:cNvPr id="2" name="Slide Image Placeholder 1"/>
           <p:cNvSpPr>
-            <a:spLocks xmlns:a="http://schemas.openxmlformats.org/drawingml/2006/main" noGrp="1"/>
+            <a:spLocks noGrp="1"/>
           </p:cNvSpPr>
           <p:nvPr>
             <p:ph type="sldImg" idx="0"/>
@@ -20115,7 +20238,7 @@
         <p:nvSpPr>
           <p:cNvPr id="3" name="Notes Placeholder 2"/>
           <p:cNvSpPr>
-            <a:spLocks xmlns:a="http://schemas.openxmlformats.org/drawingml/2006/main" noGrp="1"/>
+            <a:spLocks noGrp="1"/>
           </p:cNvSpPr>
           <p:nvPr>
             <p:ph type="body" idx="1"/>
@@ -20123,42 +20246,42 @@
         </p:nvSpPr>
         <p:spPr/>
         <p:txBody>
-          <a:bodyPr xmlns:a="http://schemas.openxmlformats.org/drawingml/2006/main"/>
-          <a:lstStyle xmlns:a="http://schemas.openxmlformats.org/drawingml/2006/main"/>
-          <a:p xmlns:a="http://schemas.openxmlformats.org/drawingml/2006/main">
+          <a:bodyPr/>
+          <a:lstStyle/>
+          <a:p>
             <a:r>
-              <a:t>The input SHA-256 for this lesson is 1f96d6f1aaa36c117ccd7fb94b172a1c1435585d54279e8cffb93df0299c7204. Kernels cache imported modules, which is why a restart matters. Retain the exact graph normalization and boundary mode for source reproduction. If experimenting with other seeds, K, epochs or graph settings, rerun the matching scratch notebook as well.</a:t>
+              <a:t>For a missing input, download the H5AD file from the repository's BC-515 data release and place it in data/. Running python check_setup.py checks the file checksum and dependencies.</a:t>
             </a:r>
           </a:p>
-          <a:p xmlns:a="http://schemas.openxmlformats.org/drawingml/2006/main">
+          <a:p>
             <a:r>
               <a:t/>
             </a:r>
             <a:endParaRPr/>
           </a:p>
-          <a:p xmlns:a="http://schemas.openxmlformats.org/drawingml/2006/main">
+          <a:p>
             <a:r>
-              <a:t>Sources</a:t>
+              <a:t>If SIGMA reports an unexpected version, restart the kernel before rerunning the source-path cell. Python keeps imported modules in memory, so changing the path alone may leave the previous import active. For the pinned MET-MAP source, keep loss_threshold=-1.0 to bypass the branch that references corr_loss.</a:t>
             </a:r>
           </a:p>
-          <a:p xmlns:a="http://schemas.openxmlformats.org/drawingml/2006/main">
+          <a:p>
             <a:r>
-              <a:t>notebooks/BC515_four_implementations/README.md</a:t>
+              <a:t/>
             </a:r>
           </a:p>
-          <a:p xmlns:a="http://schemas.openxmlformats.org/drawingml/2006/main">
+          <a:p>
             <a:r>
-              <a:t>notebooks/BC515_four_implementations/verification.json</a:t>
+              <a:t>If paired results differ, compare the input checksum, spot order and package versions, then rerun both notebooks with identical settings. SIGMA also needs a valid split and boundary before it can calculate signed distance. Check the score range if no boundary appears.</a:t>
             </a:r>
           </a:p>
-          <a:p xmlns:a="http://schemas.openxmlformats.org/drawingml/2006/main">
+          <a:p>
             <a:r>
-              <a:t>external/MET-MAP/src/multi_gaston/multi_gaston.py, commit 43c9386ffe7d5b2f0f66d64d4820358c3cd8a11c</a:t>
+              <a:t/>
             </a:r>
           </a:p>
-          <a:p xmlns:a="http://schemas.openxmlformats.org/drawingml/2006/main">
+          <a:p>
             <a:r>
-              <a:t>sigma_spatial_pypi_starter/src/sigma_spatial</a:t>
+              <a:t>Sources: DATA.md, check_setup.py, README.md, 01_METMAP_library.ipynb, 02_SIGMA_library.ipynb.</a:t>
             </a:r>
           </a:p>
         </p:txBody>
@@ -20167,7 +20290,7 @@
         <p:nvSpPr>
           <p:cNvPr id="4" name="Slide Number Placeholder 3"/>
           <p:cNvSpPr>
-            <a:spLocks xmlns:a="http://schemas.openxmlformats.org/drawingml/2006/main" noGrp="1"/>
+            <a:spLocks noGrp="1"/>
           </p:cNvSpPr>
           <p:nvPr>
             <p:ph type="sldNum" idx="5"/>
@@ -20175,21 +20298,21 @@
         </p:nvSpPr>
         <p:spPr/>
         <p:txBody>
-          <a:bodyPr xmlns:a="http://schemas.openxmlformats.org/drawingml/2006/main"/>
-          <a:lstStyle xmlns:a="http://schemas.openxmlformats.org/drawingml/2006/main"/>
-          <a:p xmlns:a="http://schemas.openxmlformats.org/drawingml/2006/main"/>
+          <a:bodyPr/>
+          <a:lstStyle/>
+          <a:p/>
         </p:txBody>
       </p:sp>
     </p:spTree>
   </p:cSld>
   <p:clrMapOvr>
-    <a:masterClrMapping xmlns:a="http://schemas.openxmlformats.org/drawingml/2006/main"/>
+    <a:masterClrMapping/>
   </p:clrMapOvr>
 </p:notes>
 </file>
 
 <file path=ppt/notesSlides/notesSlide26.xml><?xml version="1.0" encoding="utf-8"?>
-<p:notes xmlns:p="http://schemas.openxmlformats.org/presentationml/2006/main">
+<p:notes xmlns:a="http://schemas.openxmlformats.org/drawingml/2006/main" xmlns:p="http://schemas.openxmlformats.org/presentationml/2006/main">
   <p:cSld>
     <p:spTree>
       <p:nvGrpSpPr>
@@ -20198,13 +20321,13 @@
         <p:nvPr/>
       </p:nvGrpSpPr>
       <p:grpSpPr>
-        <a:xfrm xmlns:a="http://schemas.openxmlformats.org/drawingml/2006/main"/>
+        <a:xfrm/>
       </p:grpSpPr>
       <p:sp>
         <p:nvSpPr>
           <p:cNvPr id="2" name="Slide Image Placeholder 1"/>
           <p:cNvSpPr>
-            <a:spLocks xmlns:a="http://schemas.openxmlformats.org/drawingml/2006/main" noGrp="1"/>
+            <a:spLocks noGrp="1"/>
           </p:cNvSpPr>
           <p:nvPr>
             <p:ph type="sldImg" idx="0"/>
@@ -20216,7 +20339,7 @@
         <p:nvSpPr>
           <p:cNvPr id="3" name="Notes Placeholder 2"/>
           <p:cNvSpPr>
-            <a:spLocks xmlns:a="http://schemas.openxmlformats.org/drawingml/2006/main" noGrp="1"/>
+            <a:spLocks noGrp="1"/>
           </p:cNvSpPr>
           <p:nvPr>
             <p:ph type="body" idx="1"/>
@@ -20224,11 +20347,31 @@
         </p:nvSpPr>
         <p:spPr/>
         <p:txBody>
-          <a:bodyPr xmlns:a="http://schemas.openxmlformats.org/drawingml/2006/main"/>
-          <a:lstStyle xmlns:a="http://schemas.openxmlformats.org/drawingml/2006/main"/>
-          <a:p xmlns:a="http://schemas.openxmlformats.org/drawingml/2006/main">
+          <a:bodyPr/>
+          <a:lstStyle/>
+          <a:p>
             <a:r>
-              <a:t>MET-MAP is a fixed-parameter adaptation to BC-515. SIGMA follows the original BC-515 training and lambda/program workflow using the documented compatibility source. The notebooks check agreement between implementations for one data file and environment. Their results do not establish held-out predictive performance or chemical identities. References: Samarah et al., Nature 648, 182–190 (2025), doi:10.1038/s41586-025-09616-5; github.com/raphael-group/MET-MAP; github.com/Elsa-bingxue/SIGMA.</a:t>
+              <a:t>The MET-MAP example applies a fixed model configuration to BC-515. The SIGMA example follows the original BC-515 training, decay-fit and metabolic-program workflow. In each case, the library and notebook implementations agree for this input and environment.</a:t>
+            </a:r>
+          </a:p>
+          <a:p>
+            <a:r>
+              <a:t/>
+            </a:r>
+          </a:p>
+          <a:p>
+            <a:r>
+              <a:t>Biological interpretation needs evidence beyond these computational checks. Training fit and agreement with the supplied labels leave performance on independent sections untested. Chemical identification also requires more than an m/z value. The MET-MAP paper and both source repositories provide the background for further work.</a:t>
+            </a:r>
+          </a:p>
+          <a:p>
+            <a:r>
+              <a:t/>
+            </a:r>
+          </a:p>
+          <a:p>
+            <a:r>
+              <a:t>References: Samarah et al., Nature 648, 182–190 (2025), https://doi.org/10.1038/s41586-025-09616-5. https://github.com/raphael-group/MET-MAP. https://github.com/Elsa-bingxue/SIGMA.</a:t>
             </a:r>
           </a:p>
         </p:txBody>
@@ -20237,7 +20380,7 @@
         <p:nvSpPr>
           <p:cNvPr id="4" name="Slide Number Placeholder 3"/>
           <p:cNvSpPr>
-            <a:spLocks xmlns:a="http://schemas.openxmlformats.org/drawingml/2006/main" noGrp="1"/>
+            <a:spLocks noGrp="1"/>
           </p:cNvSpPr>
           <p:nvPr>
             <p:ph type="sldNum" idx="5"/>
@@ -20245,21 +20388,21 @@
         </p:nvSpPr>
         <p:spPr/>
         <p:txBody>
-          <a:bodyPr xmlns:a="http://schemas.openxmlformats.org/drawingml/2006/main"/>
-          <a:lstStyle xmlns:a="http://schemas.openxmlformats.org/drawingml/2006/main"/>
-          <a:p xmlns:a="http://schemas.openxmlformats.org/drawingml/2006/main"/>
+          <a:bodyPr/>
+          <a:lstStyle/>
+          <a:p/>
         </p:txBody>
       </p:sp>
     </p:spTree>
   </p:cSld>
   <p:clrMapOvr>
-    <a:masterClrMapping xmlns:a="http://schemas.openxmlformats.org/drawingml/2006/main"/>
+    <a:masterClrMapping/>
   </p:clrMapOvr>
 </p:notes>
 </file>
 
 <file path=ppt/notesSlides/notesSlide27.xml><?xml version="1.0" encoding="utf-8"?>
-<p:notes xmlns:p="http://schemas.openxmlformats.org/presentationml/2006/main">
+<p:notes xmlns:a="http://schemas.openxmlformats.org/drawingml/2006/main" xmlns:p="http://schemas.openxmlformats.org/presentationml/2006/main">
   <p:cSld>
     <p:spTree>
       <p:nvGrpSpPr>
@@ -20268,13 +20411,13 @@
         <p:nvPr/>
       </p:nvGrpSpPr>
       <p:grpSpPr>
-        <a:xfrm xmlns:a="http://schemas.openxmlformats.org/drawingml/2006/main"/>
+        <a:xfrm/>
       </p:grpSpPr>
       <p:sp>
         <p:nvSpPr>
           <p:cNvPr id="2" name="Slide Image Placeholder 1"/>
           <p:cNvSpPr>
-            <a:spLocks xmlns:a="http://schemas.openxmlformats.org/drawingml/2006/main" noGrp="1"/>
+            <a:spLocks noGrp="1"/>
           </p:cNvSpPr>
           <p:nvPr>
             <p:ph type="sldImg" idx="0"/>
@@ -20286,7 +20429,7 @@
         <p:nvSpPr>
           <p:cNvPr id="3" name="Notes Placeholder 2"/>
           <p:cNvSpPr>
-            <a:spLocks xmlns:a="http://schemas.openxmlformats.org/drawingml/2006/main" noGrp="1"/>
+            <a:spLocks noGrp="1"/>
           </p:cNvSpPr>
           <p:nvPr>
             <p:ph type="body" idx="1"/>
@@ -20294,9 +20437,9 @@
         </p:nvSpPr>
         <p:spPr/>
         <p:txBody>
-          <a:bodyPr xmlns:a="http://schemas.openxmlformats.org/drawingml/2006/main"/>
-          <a:lstStyle xmlns:a="http://schemas.openxmlformats.org/drawingml/2006/main"/>
-          <a:p xmlns:a="http://schemas.openxmlformats.org/drawingml/2006/main">
+          <a:bodyPr/>
+          <a:lstStyle/>
+          <a:p>
             <a:pPr marL="0" marR="0" lvl="0" indent="0" algn="l" defTabSz="914400">
               <a:lnSpc>
                 <a:spcPct val="100000"/>
@@ -20314,24 +20457,29 @@
             </a:pPr>
             <a:r>
               <a:rPr b="1"/>
-              <a:t>Discussion prompts: How would changing K alter the MET-MAP representation? Which SIGMA outputs would change if RNA supervision were removed? What additional data would support a biological interpretation of the top-ranked MSI features? Parameter changes are classroom extensions and are not part of the saved baseline run.</a:t>
+              <a:t>How does changing K affect the MET-MAP gradients? For SIGMA, what changes when we remove the RNA loss? Both are useful exercises after reproducing the supplied settings.</a:t>
             </a:r>
             <a:endParaRPr/>
           </a:p>
-          <a:p xmlns:a="http://schemas.openxmlformats.org/drawingml/2006/main">
+          <a:p>
             <a:r>
               <a:t/>
             </a:r>
             <a:endParaRPr/>
           </a:p>
-          <a:p xmlns:a="http://schemas.openxmlformats.org/drawingml/2006/main">
+          <a:p>
             <a:r>
-              <a:t>Sources</a:t>
+              <a:t>For a biological follow-up, what evidence would identify a representative MSI feature and show that its spatial pattern recurs in another section?</a:t>
             </a:r>
           </a:p>
-          <a:p xmlns:a="http://schemas.openxmlformats.org/drawingml/2006/main">
+          <a:p>
             <a:r>
-              <a:t>notebooks/BC515_four_implementations/README.md</a:t>
+              <a:t/>
+            </a:r>
+          </a:p>
+          <a:p>
+            <a:r>
+              <a:t>Sources: 01_METMAP_library.ipynb, 02_SIGMA_library.ipynb.</a:t>
             </a:r>
           </a:p>
         </p:txBody>
@@ -20340,7 +20488,7 @@
         <p:nvSpPr>
           <p:cNvPr id="4" name="Slide Number Placeholder 3"/>
           <p:cNvSpPr>
-            <a:spLocks xmlns:a="http://schemas.openxmlformats.org/drawingml/2006/main" noGrp="1"/>
+            <a:spLocks noGrp="1"/>
           </p:cNvSpPr>
           <p:nvPr>
             <p:ph type="sldNum" idx="5"/>
@@ -20348,21 +20496,21 @@
         </p:nvSpPr>
         <p:spPr/>
         <p:txBody>
-          <a:bodyPr xmlns:a="http://schemas.openxmlformats.org/drawingml/2006/main"/>
-          <a:lstStyle xmlns:a="http://schemas.openxmlformats.org/drawingml/2006/main"/>
-          <a:p xmlns:a="http://schemas.openxmlformats.org/drawingml/2006/main"/>
+          <a:bodyPr/>
+          <a:lstStyle/>
+          <a:p/>
         </p:txBody>
       </p:sp>
     </p:spTree>
   </p:cSld>
   <p:clrMapOvr>
-    <a:masterClrMapping xmlns:a="http://schemas.openxmlformats.org/drawingml/2006/main"/>
+    <a:masterClrMapping/>
   </p:clrMapOvr>
 </p:notes>
 </file>
 
 <file path=ppt/notesSlides/notesSlide3.xml><?xml version="1.0" encoding="utf-8"?>
-<p:notes xmlns:p="http://schemas.openxmlformats.org/presentationml/2006/main">
+<p:notes xmlns:a="http://schemas.openxmlformats.org/drawingml/2006/main" xmlns:p="http://schemas.openxmlformats.org/presentationml/2006/main">
   <p:cSld>
     <p:spTree>
       <p:nvGrpSpPr>
@@ -20371,13 +20519,13 @@
         <p:nvPr/>
       </p:nvGrpSpPr>
       <p:grpSpPr>
-        <a:xfrm xmlns:a="http://schemas.openxmlformats.org/drawingml/2006/main"/>
+        <a:xfrm/>
       </p:grpSpPr>
       <p:sp>
         <p:nvSpPr>
           <p:cNvPr id="2" name="Slide Image Placeholder 1"/>
           <p:cNvSpPr>
-            <a:spLocks xmlns:a="http://schemas.openxmlformats.org/drawingml/2006/main" noGrp="1"/>
+            <a:spLocks noGrp="1"/>
           </p:cNvSpPr>
           <p:nvPr>
             <p:ph type="sldImg" idx="0"/>
@@ -20389,7 +20537,7 @@
         <p:nvSpPr>
           <p:cNvPr id="3" name="Notes Placeholder 2"/>
           <p:cNvSpPr>
-            <a:spLocks xmlns:a="http://schemas.openxmlformats.org/drawingml/2006/main" noGrp="1"/>
+            <a:spLocks noGrp="1"/>
           </p:cNvSpPr>
           <p:nvPr>
             <p:ph type="body" idx="1"/>
@@ -20397,32 +20545,32 @@
         </p:nvSpPr>
         <p:spPr/>
         <p:txBody>
-          <a:bodyPr xmlns:a="http://schemas.openxmlformats.org/drawingml/2006/main"/>
-          <a:lstStyle xmlns:a="http://schemas.openxmlformats.org/drawingml/2006/main"/>
-          <a:p xmlns:a="http://schemas.openxmlformats.org/drawingml/2006/main">
+          <a:bodyPr/>
+          <a:lstStyle/>
+          <a:p>
             <a:r>
-              <a:t>Show the annotation map before model outputs. All 77 unlabelled spots remain in the graph and reconstructed matrices. SIGMA excludes them only from the supervised binary cross-entropy term. These annotations also appear on MET-MAP figures for interpretation, without entering MET-MAP training.</a:t>
+              <a:t>This section contains 3,508 spots and 2,086 measured MSI features. Most spots are annotated as Stroma, with 724 Tumor spots and 77 unlabelled spots. We keep all of them in the analysis.</a:t>
             </a:r>
           </a:p>
-          <a:p xmlns:a="http://schemas.openxmlformats.org/drawingml/2006/main">
+          <a:p>
             <a:r>
               <a:t/>
             </a:r>
             <a:endParaRPr/>
           </a:p>
-          <a:p xmlns:a="http://schemas.openxmlformats.org/drawingml/2006/main">
+          <a:p>
             <a:r>
-              <a:t>Sources</a:t>
+              <a:t>For SIGMA, the unlabelled spots still contribute to the graph and reconstruction terms. Only the labelled spots contribute to the supervised classification loss. For MET-MAP, the annotations enter only the interpretation of the maps after fitting.</a:t>
             </a:r>
           </a:p>
-          <a:p xmlns:a="http://schemas.openxmlformats.org/drawingml/2006/main">
+          <a:p>
             <a:r>
-              <a:t>data/BC_515_Section_1.h5ad</a:t>
+              <a:t/>
             </a:r>
           </a:p>
-          <a:p xmlns:a="http://schemas.openxmlformats.org/drawingml/2006/main">
+          <a:p>
             <a:r>
-              <a:t>notebooks/BC515_four_implementations/results/metmap_library/provenance.json</a:t>
+              <a:t>Sources: data/BC_515_Section_1.h5ad, 01_METMAP_library.ipynb, 02_SIGMA_library.ipynb.</a:t>
             </a:r>
           </a:p>
         </p:txBody>
@@ -20431,7 +20579,7 @@
         <p:nvSpPr>
           <p:cNvPr id="4" name="Slide Number Placeholder 3"/>
           <p:cNvSpPr>
-            <a:spLocks xmlns:a="http://schemas.openxmlformats.org/drawingml/2006/main" noGrp="1"/>
+            <a:spLocks noGrp="1"/>
           </p:cNvSpPr>
           <p:nvPr>
             <p:ph type="sldNum" idx="5"/>
@@ -20439,21 +20587,21 @@
         </p:nvSpPr>
         <p:spPr/>
         <p:txBody>
-          <a:bodyPr xmlns:a="http://schemas.openxmlformats.org/drawingml/2006/main"/>
-          <a:lstStyle xmlns:a="http://schemas.openxmlformats.org/drawingml/2006/main"/>
-          <a:p xmlns:a="http://schemas.openxmlformats.org/drawingml/2006/main"/>
+          <a:bodyPr/>
+          <a:lstStyle/>
+          <a:p/>
         </p:txBody>
       </p:sp>
     </p:spTree>
   </p:cSld>
   <p:clrMapOvr>
-    <a:masterClrMapping xmlns:a="http://schemas.openxmlformats.org/drawingml/2006/main"/>
+    <a:masterClrMapping/>
   </p:clrMapOvr>
 </p:notes>
 </file>
 
 <file path=ppt/notesSlides/notesSlide4.xml><?xml version="1.0" encoding="utf-8"?>
-<p:notes xmlns:p="http://schemas.openxmlformats.org/presentationml/2006/main">
+<p:notes xmlns:a="http://schemas.openxmlformats.org/drawingml/2006/main" xmlns:p="http://schemas.openxmlformats.org/presentationml/2006/main">
   <p:cSld>
     <p:spTree>
       <p:nvGrpSpPr>
@@ -20462,13 +20610,13 @@
         <p:nvPr/>
       </p:nvGrpSpPr>
       <p:grpSpPr>
-        <a:xfrm xmlns:a="http://schemas.openxmlformats.org/drawingml/2006/main"/>
+        <a:xfrm/>
       </p:grpSpPr>
       <p:sp>
         <p:nvSpPr>
           <p:cNvPr id="2" name="Slide Image Placeholder 1"/>
           <p:cNvSpPr>
-            <a:spLocks xmlns:a="http://schemas.openxmlformats.org/drawingml/2006/main" noGrp="1"/>
+            <a:spLocks noGrp="1"/>
           </p:cNvSpPr>
           <p:nvPr>
             <p:ph type="sldImg" idx="0"/>
@@ -20480,7 +20628,7 @@
         <p:nvSpPr>
           <p:cNvPr id="3" name="Notes Placeholder 2"/>
           <p:cNvSpPr>
-            <a:spLocks xmlns:a="http://schemas.openxmlformats.org/drawingml/2006/main" noGrp="1"/>
+            <a:spLocks noGrp="1"/>
           </p:cNvSpPr>
           <p:nvPr>
             <p:ph type="body" idx="1"/>
@@ -20488,11 +20636,31 @@
         </p:nvSpPr>
         <p:spPr/>
         <p:txBody>
-          <a:bodyPr xmlns:a="http://schemas.openxmlformats.org/drawingml/2006/main"/>
-          <a:lstStyle xmlns:a="http://schemas.openxmlformats.org/drawingml/2006/main"/>
-          <a:p xmlns:a="http://schemas.openxmlformats.org/drawingml/2006/main">
+          <a:bodyPr/>
+          <a:lstStyle/>
+          <a:p>
             <a:r>
-              <a:t>The repository contains four executed notebooks. MET-MAP uses the pinned upstream source; SIGMA uses a bundled source snapshot with documented changes that restore the original BC-515 computation. The scratch notebooks implement the methods in their own cells. Source: repository README.md and vendor/SIGMA compatibility notes.</a:t>
+              <a:t>The notebooks form two pairs: 01 and 03 for MET-MAP, and 02 and 04 for SIGMA. Each pair uses the same inputs and settings, with comparison cells at the end to check that the calculations agree.</a:t>
+            </a:r>
+          </a:p>
+          <a:p>
+            <a:r>
+              <a:t/>
+            </a:r>
+          </a:p>
+          <a:p>
+            <a:r>
+              <a:t>The MET-MAP library notebook imports a fixed upstream source version. The SIGMA library notebook imports the bundled version that follows the original BC-515 workflow. In the two scratch notebooks, the model and analysis steps are defined in the cells, so we can inspect how the outputs are calculated.</a:t>
+            </a:r>
+          </a:p>
+          <a:p>
+            <a:r>
+              <a:t/>
+            </a:r>
+          </a:p>
+          <a:p>
+            <a:r>
+              <a:t>Sources: README.md, vendor/SIGMA/ORIGINAL_COMPATIBILITY.md.</a:t>
             </a:r>
           </a:p>
         </p:txBody>
@@ -20501,7 +20669,7 @@
         <p:nvSpPr>
           <p:cNvPr id="4" name="Slide Number Placeholder 3"/>
           <p:cNvSpPr>
-            <a:spLocks xmlns:a="http://schemas.openxmlformats.org/drawingml/2006/main" noGrp="1"/>
+            <a:spLocks noGrp="1"/>
           </p:cNvSpPr>
           <p:nvPr>
             <p:ph type="sldNum" idx="5"/>
@@ -20509,21 +20677,21 @@
         </p:nvSpPr>
         <p:spPr/>
         <p:txBody>
-          <a:bodyPr xmlns:a="http://schemas.openxmlformats.org/drawingml/2006/main"/>
-          <a:lstStyle xmlns:a="http://schemas.openxmlformats.org/drawingml/2006/main"/>
-          <a:p xmlns:a="http://schemas.openxmlformats.org/drawingml/2006/main"/>
+          <a:bodyPr/>
+          <a:lstStyle/>
+          <a:p/>
         </p:txBody>
       </p:sp>
     </p:spTree>
   </p:cSld>
   <p:clrMapOvr>
-    <a:masterClrMapping xmlns:a="http://schemas.openxmlformats.org/drawingml/2006/main"/>
+    <a:masterClrMapping/>
   </p:clrMapOvr>
 </p:notes>
 </file>
 
 <file path=ppt/notesSlides/notesSlide5.xml><?xml version="1.0" encoding="utf-8"?>
-<p:notes xmlns:p="http://schemas.openxmlformats.org/presentationml/2006/main">
+<p:notes xmlns:a="http://schemas.openxmlformats.org/drawingml/2006/main" xmlns:p="http://schemas.openxmlformats.org/presentationml/2006/main">
   <p:cSld>
     <p:spTree>
       <p:nvGrpSpPr>
@@ -20532,13 +20700,13 @@
         <p:nvPr/>
       </p:nvGrpSpPr>
       <p:grpSpPr>
-        <a:xfrm xmlns:a="http://schemas.openxmlformats.org/drawingml/2006/main"/>
+        <a:xfrm/>
       </p:grpSpPr>
       <p:sp>
         <p:nvSpPr>
           <p:cNvPr id="2" name="Slide Image Placeholder 1"/>
           <p:cNvSpPr>
-            <a:spLocks xmlns:a="http://schemas.openxmlformats.org/drawingml/2006/main" noGrp="1"/>
+            <a:spLocks noGrp="1"/>
           </p:cNvSpPr>
           <p:nvPr>
             <p:ph type="sldImg" idx="0"/>
@@ -20550,7 +20718,7 @@
         <p:nvSpPr>
           <p:cNvPr id="3" name="Notes Placeholder 2"/>
           <p:cNvSpPr>
-            <a:spLocks xmlns:a="http://schemas.openxmlformats.org/drawingml/2006/main" noGrp="1"/>
+            <a:spLocks noGrp="1"/>
           </p:cNvSpPr>
           <p:nvPr>
             <p:ph type="body" idx="1"/>
@@ -20558,11 +20726,31 @@
         </p:nvSpPr>
         <p:spPr/>
         <p:txBody>
-          <a:bodyPr xmlns:a="http://schemas.openxmlformats.org/drawingml/2006/main"/>
-          <a:lstStyle xmlns:a="http://schemas.openxmlformats.org/drawingml/2006/main"/>
-          <a:p xmlns:a="http://schemas.openxmlformats.org/drawingml/2006/main">
+          <a:bodyPr/>
+          <a:lstStyle/>
+          <a:p>
             <a:r>
-              <a:t>Run these commands from the downloaded repository folder. Python 3.11 and requirements.txt define the course environment. Obtain the processed course H5AD separately and follow DATA.md. BC515_DATA can point to an external copy. The code uses CPU; a GPU is not required.</a:t>
+              <a:t>Run these commands from the downloaded repository folder. Use Python 3.11 and install the versions listed in requirements.txt. Download BC_515_Section_1.h5ad from the repository's bc515-data-v1 release and place it in data/. If you already have a copy elsewhere, BC515_DATA can point to that file.</a:t>
+            </a:r>
+          </a:p>
+          <a:p>
+            <a:r>
+              <a:t/>
+            </a:r>
+          </a:p>
+          <a:p>
+            <a:r>
+              <a:t>Run check_setup.py before opening JupyterLab. Then open a notebook, restart its kernel and run all cells in order. The notebooks use the libraries in vendor/ and run on the CPU. No GPU is needed.</a:t>
+            </a:r>
+          </a:p>
+          <a:p>
+            <a:r>
+              <a:t/>
+            </a:r>
+          </a:p>
+          <a:p>
+            <a:r>
+              <a:t>Sources: README.md, DATA.md, requirements.txt. Data release: https://github.com/Elsa-bingxue/METMAP-SIGMA-Tutorials/releases/tag/bc515-data-v1.</a:t>
             </a:r>
           </a:p>
         </p:txBody>
@@ -20571,7 +20759,7 @@
         <p:nvSpPr>
           <p:cNvPr id="4" name="Slide Number Placeholder 3"/>
           <p:cNvSpPr>
-            <a:spLocks xmlns:a="http://schemas.openxmlformats.org/drawingml/2006/main" noGrp="1"/>
+            <a:spLocks noGrp="1"/>
           </p:cNvSpPr>
           <p:nvPr>
             <p:ph type="sldNum" idx="5"/>
@@ -20579,21 +20767,21 @@
         </p:nvSpPr>
         <p:spPr/>
         <p:txBody>
-          <a:bodyPr xmlns:a="http://schemas.openxmlformats.org/drawingml/2006/main"/>
-          <a:lstStyle xmlns:a="http://schemas.openxmlformats.org/drawingml/2006/main"/>
-          <a:p xmlns:a="http://schemas.openxmlformats.org/drawingml/2006/main"/>
+          <a:bodyPr/>
+          <a:lstStyle/>
+          <a:p/>
         </p:txBody>
       </p:sp>
     </p:spTree>
   </p:cSld>
   <p:clrMapOvr>
-    <a:masterClrMapping xmlns:a="http://schemas.openxmlformats.org/drawingml/2006/main"/>
+    <a:masterClrMapping/>
   </p:clrMapOvr>
 </p:notes>
 </file>
 
 <file path=ppt/notesSlides/notesSlide6.xml><?xml version="1.0" encoding="utf-8"?>
-<p:notes xmlns:p="http://schemas.openxmlformats.org/presentationml/2006/main">
+<p:notes xmlns:a="http://schemas.openxmlformats.org/drawingml/2006/main" xmlns:p="http://schemas.openxmlformats.org/presentationml/2006/main">
   <p:cSld>
     <p:spTree>
       <p:nvGrpSpPr>
@@ -20602,13 +20790,13 @@
         <p:nvPr/>
       </p:nvGrpSpPr>
       <p:grpSpPr>
-        <a:xfrm xmlns:a="http://schemas.openxmlformats.org/drawingml/2006/main"/>
+        <a:xfrm/>
       </p:grpSpPr>
       <p:sp>
         <p:nvSpPr>
           <p:cNvPr id="2" name="Slide Image Placeholder 1"/>
           <p:cNvSpPr>
-            <a:spLocks xmlns:a="http://schemas.openxmlformats.org/drawingml/2006/main" noGrp="1"/>
+            <a:spLocks noGrp="1"/>
           </p:cNvSpPr>
           <p:nvPr>
             <p:ph type="sldImg" idx="0"/>
@@ -20620,7 +20808,7 @@
         <p:nvSpPr>
           <p:cNvPr id="3" name="Notes Placeholder 2"/>
           <p:cNvSpPr>
-            <a:spLocks xmlns:a="http://schemas.openxmlformats.org/drawingml/2006/main" noGrp="1"/>
+            <a:spLocks noGrp="1"/>
           </p:cNvSpPr>
           <p:nvPr>
             <p:ph type="body" idx="1"/>
@@ -20628,32 +20816,32 @@
         </p:nvSpPr>
         <p:spPr/>
         <p:txBody>
-          <a:bodyPr xmlns:a="http://schemas.openxmlformats.org/drawingml/2006/main"/>
-          <a:lstStyle xmlns:a="http://schemas.openxmlformats.org/drawingml/2006/main"/>
-          <a:p xmlns:a="http://schemas.openxmlformats.org/drawingml/2006/main">
+          <a:bodyPr/>
+          <a:lstStyle/>
+          <a:p>
             <a:r>
-              <a:t>The snippets assume the notebook has already found ROOT and imported anndata as ad and numpy as np. The notebooks preserve the original spot ordering. X_harmony contains a precomputed RNA representation. This lesson does not repeat the upstream Harmony integration.</a:t>
+              <a:t>The MSI matrix is stored in adata.uns["msi"]. This matters because adata.X contains RNA expression, and using it would change the analysis entirely. The m/z values, spatial coordinates and annotations must retain the same spot and feature ordering as the intensity matrix.</a:t>
             </a:r>
           </a:p>
-          <a:p xmlns:a="http://schemas.openxmlformats.org/drawingml/2006/main">
+          <a:p>
             <a:r>
               <a:t/>
             </a:r>
             <a:endParaRPr/>
           </a:p>
-          <a:p xmlns:a="http://schemas.openxmlformats.org/drawingml/2006/main">
+          <a:p>
             <a:r>
-              <a:t>Sources</a:t>
+              <a:t>SIGMA also takes the first 32 columns of X_harmony as its RNA target. That representation is already present in the course file. We do not recompute Harmony here. Run the notebook's setup cells first so that its imports and repository path are defined.</a:t>
             </a:r>
           </a:p>
-          <a:p xmlns:a="http://schemas.openxmlformats.org/drawingml/2006/main">
+          <a:p>
             <a:r>
-              <a:t>notebooks/BC515_four_implementations/01_METMAP_library.ipynb</a:t>
+              <a:t/>
             </a:r>
           </a:p>
-          <a:p xmlns:a="http://schemas.openxmlformats.org/drawingml/2006/main">
+          <a:p>
             <a:r>
-              <a:t>notebooks/BC515_four_implementations/02_SIGMA_library.ipynb</a:t>
+              <a:t>Sources: 01_METMAP_library.ipynb, 02_SIGMA_library.ipynb.</a:t>
             </a:r>
           </a:p>
         </p:txBody>
@@ -20662,7 +20850,7 @@
         <p:nvSpPr>
           <p:cNvPr id="4" name="Slide Number Placeholder 3"/>
           <p:cNvSpPr>
-            <a:spLocks xmlns:a="http://schemas.openxmlformats.org/drawingml/2006/main" noGrp="1"/>
+            <a:spLocks noGrp="1"/>
           </p:cNvSpPr>
           <p:nvPr>
             <p:ph type="sldNum" idx="5"/>
@@ -20670,21 +20858,21 @@
         </p:nvSpPr>
         <p:spPr/>
         <p:txBody>
-          <a:bodyPr xmlns:a="http://schemas.openxmlformats.org/drawingml/2006/main"/>
-          <a:lstStyle xmlns:a="http://schemas.openxmlformats.org/drawingml/2006/main"/>
-          <a:p xmlns:a="http://schemas.openxmlformats.org/drawingml/2006/main"/>
+          <a:bodyPr/>
+          <a:lstStyle/>
+          <a:p/>
         </p:txBody>
       </p:sp>
     </p:spTree>
   </p:cSld>
   <p:clrMapOvr>
-    <a:masterClrMapping xmlns:a="http://schemas.openxmlformats.org/drawingml/2006/main"/>
+    <a:masterClrMapping/>
   </p:clrMapOvr>
 </p:notes>
 </file>
 
 <file path=ppt/notesSlides/notesSlide7.xml><?xml version="1.0" encoding="utf-8"?>
-<p:notes xmlns:p="http://schemas.openxmlformats.org/presentationml/2006/main">
+<p:notes xmlns:a="http://schemas.openxmlformats.org/drawingml/2006/main" xmlns:p="http://schemas.openxmlformats.org/presentationml/2006/main">
   <p:cSld>
     <p:spTree>
       <p:nvGrpSpPr>
@@ -20693,13 +20881,13 @@
         <p:nvPr/>
       </p:nvGrpSpPr>
       <p:grpSpPr>
-        <a:xfrm xmlns:a="http://schemas.openxmlformats.org/drawingml/2006/main"/>
+        <a:xfrm/>
       </p:grpSpPr>
       <p:sp>
         <p:nvSpPr>
           <p:cNvPr id="2" name="Slide Image Placeholder 1"/>
           <p:cNvSpPr>
-            <a:spLocks xmlns:a="http://schemas.openxmlformats.org/drawingml/2006/main" noGrp="1"/>
+            <a:spLocks noGrp="1"/>
           </p:cNvSpPr>
           <p:nvPr>
             <p:ph type="sldImg" idx="0"/>
@@ -20711,7 +20899,7 @@
         <p:nvSpPr>
           <p:cNvPr id="3" name="Notes Placeholder 2"/>
           <p:cNvSpPr>
-            <a:spLocks xmlns:a="http://schemas.openxmlformats.org/drawingml/2006/main" noGrp="1"/>
+            <a:spLocks noGrp="1"/>
           </p:cNvSpPr>
           <p:nvPr>
             <p:ph type="body" idx="1"/>
@@ -20719,32 +20907,32 @@
         </p:nvSpPr>
         <p:spPr/>
         <p:txBody>
-          <a:bodyPr xmlns:a="http://schemas.openxmlformats.org/drawingml/2006/main"/>
-          <a:lstStyle xmlns:a="http://schemas.openxmlformats.org/drawingml/2006/main"/>
-          <a:p xmlns:a="http://schemas.openxmlformats.org/drawingml/2006/main">
+          <a:bodyPr/>
+          <a:lstStyle/>
+          <a:p>
             <a:r>
-              <a:t>The chosen BC-515 model has a 2–120–120–3 encoder and a 3–2086 decoder. K=3 is a lesson configuration, not a universal dimensionality. The output axes can change sign, order and scale without defining new biology. Their biological interpretation requires additional evidence. This lesson applies a fixed MET-MAP configuration to BC-515. It does not rerun the original mouse liver or intestine experiments or their hyperparameter searches.</a:t>
+              <a:t>The encoder takes two spatial coordinates through hidden layers of 120 units each and returns three isodepth values. A linear decoder then uses those three values to reconstruct all 2,086 MSI features. This makes the spatial representation small enough to inspect while allowing each feature to have its own decoder weights.</a:t>
             </a:r>
           </a:p>
-          <a:p xmlns:a="http://schemas.openxmlformats.org/drawingml/2006/main">
+          <a:p>
             <a:r>
               <a:t/>
             </a:r>
             <a:endParaRPr/>
           </a:p>
-          <a:p xmlns:a="http://schemas.openxmlformats.org/drawingml/2006/main">
+          <a:p>
             <a:r>
-              <a:t>Sources</a:t>
+              <a:t>We chose K = 3 for this BC-515 example. The axes can change sign, order and scale, so their biological interpretation requires evidence beyond the fitted maps. The original paper describes the liver and intestine experiments and their parameter searches. Here we apply one fixed configuration to BC-515.</a:t>
             </a:r>
           </a:p>
-          <a:p xmlns:a="http://schemas.openxmlformats.org/drawingml/2006/main">
+          <a:p>
             <a:r>
-              <a:t>external/MET-MAP/src/multi_gaston/multi_gaston.py, commit 43c9386ffe7d5b2f0f66d64d4820358c3cd8a11c</a:t>
+              <a:t/>
             </a:r>
           </a:p>
-          <a:p xmlns:a="http://schemas.openxmlformats.org/drawingml/2006/main">
+          <a:p>
             <a:r>
-              <a:t>Samarah et al. Spatial metabolic gradients in the liver and small intestine. Nature 648, 182–190 (2025). https://doi.org/10.1038/s41586-025-09616-5</a:t>
+              <a:t>Sources: vendor/MET-MAP/src/multi_gaston/multi_gaston.py, upstream commit 43c9386ffe7d5b2f0f66d64d4820358c3cd8a11c, Samarah et al., Nature 648, 182–190 (2025), https://doi.org/10.1038/s41586-025-09616-5.</a:t>
             </a:r>
           </a:p>
         </p:txBody>
@@ -20753,7 +20941,7 @@
         <p:nvSpPr>
           <p:cNvPr id="4" name="Slide Number Placeholder 3"/>
           <p:cNvSpPr>
-            <a:spLocks xmlns:a="http://schemas.openxmlformats.org/drawingml/2006/main" noGrp="1"/>
+            <a:spLocks noGrp="1"/>
           </p:cNvSpPr>
           <p:nvPr>
             <p:ph type="sldNum" idx="5"/>
@@ -20761,21 +20949,21 @@
         </p:nvSpPr>
         <p:spPr/>
         <p:txBody>
-          <a:bodyPr xmlns:a="http://schemas.openxmlformats.org/drawingml/2006/main"/>
-          <a:lstStyle xmlns:a="http://schemas.openxmlformats.org/drawingml/2006/main"/>
-          <a:p xmlns:a="http://schemas.openxmlformats.org/drawingml/2006/main"/>
+          <a:bodyPr/>
+          <a:lstStyle/>
+          <a:p/>
         </p:txBody>
       </p:sp>
     </p:spTree>
   </p:cSld>
   <p:clrMapOvr>
-    <a:masterClrMapping xmlns:a="http://schemas.openxmlformats.org/drawingml/2006/main"/>
+    <a:masterClrMapping/>
   </p:clrMapOvr>
 </p:notes>
 </file>
 
 <file path=ppt/notesSlides/notesSlide8.xml><?xml version="1.0" encoding="utf-8"?>
-<p:notes xmlns:p="http://schemas.openxmlformats.org/presentationml/2006/main">
+<p:notes xmlns:a="http://schemas.openxmlformats.org/drawingml/2006/main" xmlns:p="http://schemas.openxmlformats.org/presentationml/2006/main">
   <p:cSld>
     <p:spTree>
       <p:nvGrpSpPr>
@@ -20784,13 +20972,13 @@
         <p:nvPr/>
       </p:nvGrpSpPr>
       <p:grpSpPr>
-        <a:xfrm xmlns:a="http://schemas.openxmlformats.org/drawingml/2006/main"/>
+        <a:xfrm/>
       </p:grpSpPr>
       <p:sp>
         <p:nvSpPr>
           <p:cNvPr id="2" name="Slide Image Placeholder 1"/>
           <p:cNvSpPr>
-            <a:spLocks xmlns:a="http://schemas.openxmlformats.org/drawingml/2006/main" noGrp="1"/>
+            <a:spLocks noGrp="1"/>
           </p:cNvSpPr>
           <p:nvPr>
             <p:ph type="sldImg" idx="0"/>
@@ -20802,7 +20990,7 @@
         <p:nvSpPr>
           <p:cNvPr id="3" name="Notes Placeholder 2"/>
           <p:cNvSpPr>
-            <a:spLocks xmlns:a="http://schemas.openxmlformats.org/drawingml/2006/main" noGrp="1"/>
+            <a:spLocks noGrp="1"/>
           </p:cNvSpPr>
           <p:nvPr>
             <p:ph type="body" idx="1"/>
@@ -20810,32 +20998,32 @@
         </p:nvSpPr>
         <p:spPr/>
         <p:txBody>
-          <a:bodyPr xmlns:a="http://schemas.openxmlformats.org/drawingml/2006/main"/>
-          <a:lstStyle xmlns:a="http://schemas.openxmlformats.org/drawingml/2006/main"/>
-          <a:p xmlns:a="http://schemas.openxmlformats.org/drawingml/2006/main">
+          <a:bodyPr/>
+          <a:lstStyle/>
+          <a:p>
             <a:r>
-              <a:t>The measured-feature row sum approximates TIC because instrument TIC is unavailable. tensor_transform_inputs applies sklearn StandardScaler separately to coordinates and logged MSI, returning float32 tensors. This exact source version has no orthogonality, decorrelation, label or boundary loss. The scale of the MSE depends on this preprocessing.</a:t>
+              <a:t>We first adjust each spot by the sum of its measured MSI features and then apply log1p. This row sum approximates total ion count. Instrument TIC is not available in the course file. StandardScaler then standardizes each logged feature and each coordinate axis separately, and the arrays become float32 tensors.</a:t>
             </a:r>
           </a:p>
-          <a:p xmlns:a="http://schemas.openxmlformats.org/drawingml/2006/main">
+          <a:p>
             <a:r>
               <a:t/>
             </a:r>
             <a:endParaRPr/>
           </a:p>
-          <a:p xmlns:a="http://schemas.openxmlformats.org/drawingml/2006/main">
+          <a:p>
             <a:r>
-              <a:t>Sources</a:t>
+              <a:t>The objective combines mean squared reconstruction error with an L1 penalty on the decoder weights. The decoder bias remains unpenalized. Training uses MSI and coordinates, without label, boundary or orthogonality terms. The preprocessing sets the scale of the reconstruction error.</a:t>
             </a:r>
           </a:p>
-          <a:p xmlns:a="http://schemas.openxmlformats.org/drawingml/2006/main">
+          <a:p>
             <a:r>
-              <a:t>external/MET-MAP/src/multi_gaston/multi_gaston.py, commit 43c9386ffe7d5b2f0f66d64d4820358c3cd8a11c</a:t>
+              <a:t/>
             </a:r>
           </a:p>
-          <a:p xmlns:a="http://schemas.openxmlformats.org/drawingml/2006/main">
+          <a:p>
             <a:r>
-              <a:t>external/MET-MAP/src/multi_gaston/data_processing.py</a:t>
+              <a:t>Sources: vendor/MET-MAP/src/multi_gaston/data_processing.py, vendor/MET-MAP/src/multi_gaston/multi_gaston.py, upstream commit 43c9386ffe7d5b2f0f66d64d4820358c3cd8a11c.</a:t>
             </a:r>
           </a:p>
         </p:txBody>
@@ -20844,7 +21032,7 @@
         <p:nvSpPr>
           <p:cNvPr id="4" name="Slide Number Placeholder 3"/>
           <p:cNvSpPr>
-            <a:spLocks xmlns:a="http://schemas.openxmlformats.org/drawingml/2006/main" noGrp="1"/>
+            <a:spLocks noGrp="1"/>
           </p:cNvSpPr>
           <p:nvPr>
             <p:ph type="sldNum" idx="5"/>
@@ -20852,21 +21040,21 @@
         </p:nvSpPr>
         <p:spPr/>
         <p:txBody>
-          <a:bodyPr xmlns:a="http://schemas.openxmlformats.org/drawingml/2006/main"/>
-          <a:lstStyle xmlns:a="http://schemas.openxmlformats.org/drawingml/2006/main"/>
-          <a:p xmlns:a="http://schemas.openxmlformats.org/drawingml/2006/main"/>
+          <a:bodyPr/>
+          <a:lstStyle/>
+          <a:p/>
         </p:txBody>
       </p:sp>
     </p:spTree>
   </p:cSld>
   <p:clrMapOvr>
-    <a:masterClrMapping xmlns:a="http://schemas.openxmlformats.org/drawingml/2006/main"/>
+    <a:masterClrMapping/>
   </p:clrMapOvr>
 </p:notes>
 </file>
 
 <file path=ppt/notesSlides/notesSlide9.xml><?xml version="1.0" encoding="utf-8"?>
-<p:notes xmlns:p="http://schemas.openxmlformats.org/presentationml/2006/main">
+<p:notes xmlns:a="http://schemas.openxmlformats.org/drawingml/2006/main" xmlns:p="http://schemas.openxmlformats.org/presentationml/2006/main">
   <p:cSld>
     <p:spTree>
       <p:nvGrpSpPr>
@@ -20875,13 +21063,13 @@
         <p:nvPr/>
       </p:nvGrpSpPr>
       <p:grpSpPr>
-        <a:xfrm xmlns:a="http://schemas.openxmlformats.org/drawingml/2006/main"/>
+        <a:xfrm/>
       </p:grpSpPr>
       <p:sp>
         <p:nvSpPr>
           <p:cNvPr id="2" name="Slide Image Placeholder 1"/>
           <p:cNvSpPr>
-            <a:spLocks xmlns:a="http://schemas.openxmlformats.org/drawingml/2006/main" noGrp="1"/>
+            <a:spLocks noGrp="1"/>
           </p:cNvSpPr>
           <p:nvPr>
             <p:ph type="sldImg" idx="0"/>
@@ -20893,7 +21081,7 @@
         <p:nvSpPr>
           <p:cNvPr id="3" name="Notes Placeholder 2"/>
           <p:cNvSpPr>
-            <a:spLocks xmlns:a="http://schemas.openxmlformats.org/drawingml/2006/main" noGrp="1"/>
+            <a:spLocks noGrp="1"/>
           </p:cNvSpPr>
           <p:nvPr>
             <p:ph type="body" idx="1"/>
@@ -20901,32 +21089,32 @@
         </p:nvSpPr>
         <p:spPr/>
         <p:txBody>
-          <a:bodyPr xmlns:a="http://schemas.openxmlformats.org/drawingml/2006/main"/>
-          <a:lstStyle xmlns:a="http://schemas.openxmlformats.org/drawingml/2006/main"/>
-          <a:p xmlns:a="http://schemas.openxmlformats.org/drawingml/2006/main">
+          <a:bodyPr/>
+          <a:lstStyle/>
+          <a:p>
             <a:r>
-              <a:t>Run the preprocessing cells before this call. CPU selection and thread configuration occur in the notebook setup. loss_threshold=-1 disables an upstream early-stopping branch that refers to undefined corr_loss. This leaves the original source unchanged. The linear learning-rate scheduler targets a final factor of 0.05 at 12,000 steps, although this run stops at 3,000 epochs. This lesson applies a fixed MET-MAP configuration to BC-515. It does not rerun the original mouse liver or intestine experiments or their hyperparameter searches.</a:t>
+              <a:t>For execution, use the source-path cell in Notebook 01, which imports from vendor/MET-MAP/src. The notebook also sets CPU execution and the thread configuration before this training call.</a:t>
             </a:r>
           </a:p>
-          <a:p xmlns:a="http://schemas.openxmlformats.org/drawingml/2006/main">
+          <a:p>
             <a:r>
               <a:t/>
             </a:r>
             <a:endParaRPr/>
           </a:p>
-          <a:p xmlns:a="http://schemas.openxmlformats.org/drawingml/2006/main">
+          <a:p>
             <a:r>
-              <a:t>Sources</a:t>
+              <a:t>Training uses all spots in each update, with seed 0 and 3,000 epochs. Keep loss_threshold = -1.0: this avoids an early-stopping branch in the pinned source that refers to an undefined corr_loss. The linear scheduler reaches its target factor of 0.05 at 12,000 steps, so this 3,000-epoch run uses only the first part of that schedule.</a:t>
             </a:r>
           </a:p>
-          <a:p xmlns:a="http://schemas.openxmlformats.org/drawingml/2006/main">
+          <a:p>
             <a:r>
-              <a:t>notebooks/BC515_four_implementations/01_METMAP_library.ipynb</a:t>
+              <a:t/>
             </a:r>
           </a:p>
-          <a:p xmlns:a="http://schemas.openxmlformats.org/drawingml/2006/main">
+          <a:p>
             <a:r>
-              <a:t>external/MET-MAP/src/multi_gaston/multi_gaston.py, commit 43c9386ffe7d5b2f0f66d64d4820358c3cd8a11c</a:t>
+              <a:t>Sources: 01_METMAP_library.ipynb, vendor/MET-MAP/src/multi_gaston/multi_gaston.py, upstream commit 43c9386ffe7d5b2f0f66d64d4820358c3cd8a11c.</a:t>
             </a:r>
           </a:p>
         </p:txBody>
@@ -20935,7 +21123,7 @@
         <p:nvSpPr>
           <p:cNvPr id="4" name="Slide Number Placeholder 3"/>
           <p:cNvSpPr>
-            <a:spLocks xmlns:a="http://schemas.openxmlformats.org/drawingml/2006/main" noGrp="1"/>
+            <a:spLocks noGrp="1"/>
           </p:cNvSpPr>
           <p:nvPr>
             <p:ph type="sldNum" idx="5"/>
@@ -20943,15 +21131,15 @@
         </p:nvSpPr>
         <p:spPr/>
         <p:txBody>
-          <a:bodyPr xmlns:a="http://schemas.openxmlformats.org/drawingml/2006/main"/>
-          <a:lstStyle xmlns:a="http://schemas.openxmlformats.org/drawingml/2006/main"/>
-          <a:p xmlns:a="http://schemas.openxmlformats.org/drawingml/2006/main"/>
+          <a:bodyPr/>
+          <a:lstStyle/>
+          <a:p/>
         </p:txBody>
       </p:sp>
     </p:spTree>
   </p:cSld>
   <p:clrMapOvr>
-    <a:masterClrMapping xmlns:a="http://schemas.openxmlformats.org/drawingml/2006/main"/>
+    <a:masterClrMapping/>
   </p:clrMapOvr>
 </p:notes>
 </file>

</xml_diff>